<commit_message>
PDF reports and PPT finished
</commit_message>
<xml_diff>
--- a/Fraudulent_Claim_Detection.pptx
+++ b/Fraudulent_Claim_Detection.pptx
@@ -312,7 +312,7 @@
           <a:p>
             <a:fld id="{5BCAD085-E8A6-8845-BD4E-CB4CCA059FC4}" type="datetimeFigureOut">
               <a:rPr lang="en-US" smtClean="0"/>
-              <a:t>3/29/26</a:t>
+              <a:t>4/1/26</a:t>
             </a:fld>
             <a:endParaRPr lang="en-US"/>
           </a:p>
@@ -480,7 +480,7 @@
           <a:p>
             <a:fld id="{5BCAD085-E8A6-8845-BD4E-CB4CCA059FC4}" type="datetimeFigureOut">
               <a:rPr lang="en-US" smtClean="0"/>
-              <a:t>3/29/26</a:t>
+              <a:t>4/1/26</a:t>
             </a:fld>
             <a:endParaRPr lang="en-US"/>
           </a:p>
@@ -658,7 +658,7 @@
           <a:p>
             <a:fld id="{5BCAD085-E8A6-8845-BD4E-CB4CCA059FC4}" type="datetimeFigureOut">
               <a:rPr lang="en-US" smtClean="0"/>
-              <a:t>3/29/26</a:t>
+              <a:t>4/1/26</a:t>
             </a:fld>
             <a:endParaRPr lang="en-US"/>
           </a:p>
@@ -826,7 +826,7 @@
           <a:p>
             <a:fld id="{5BCAD085-E8A6-8845-BD4E-CB4CCA059FC4}" type="datetimeFigureOut">
               <a:rPr lang="en-US" smtClean="0"/>
-              <a:t>3/29/26</a:t>
+              <a:t>4/1/26</a:t>
             </a:fld>
             <a:endParaRPr lang="en-US"/>
           </a:p>
@@ -1071,7 +1071,7 @@
           <a:p>
             <a:fld id="{5BCAD085-E8A6-8845-BD4E-CB4CCA059FC4}" type="datetimeFigureOut">
               <a:rPr lang="en-US" smtClean="0"/>
-              <a:t>3/29/26</a:t>
+              <a:t>4/1/26</a:t>
             </a:fld>
             <a:endParaRPr lang="en-US"/>
           </a:p>
@@ -1356,7 +1356,7 @@
           <a:p>
             <a:fld id="{5BCAD085-E8A6-8845-BD4E-CB4CCA059FC4}" type="datetimeFigureOut">
               <a:rPr lang="en-US" smtClean="0"/>
-              <a:t>3/29/26</a:t>
+              <a:t>4/1/26</a:t>
             </a:fld>
             <a:endParaRPr lang="en-US"/>
           </a:p>
@@ -1775,7 +1775,7 @@
           <a:p>
             <a:fld id="{5BCAD085-E8A6-8845-BD4E-CB4CCA059FC4}" type="datetimeFigureOut">
               <a:rPr lang="en-US" smtClean="0"/>
-              <a:t>3/29/26</a:t>
+              <a:t>4/1/26</a:t>
             </a:fld>
             <a:endParaRPr lang="en-US"/>
           </a:p>
@@ -1892,7 +1892,7 @@
           <a:p>
             <a:fld id="{5BCAD085-E8A6-8845-BD4E-CB4CCA059FC4}" type="datetimeFigureOut">
               <a:rPr lang="en-US" smtClean="0"/>
-              <a:t>3/29/26</a:t>
+              <a:t>4/1/26</a:t>
             </a:fld>
             <a:endParaRPr lang="en-US"/>
           </a:p>
@@ -1987,7 +1987,7 @@
           <a:p>
             <a:fld id="{5BCAD085-E8A6-8845-BD4E-CB4CCA059FC4}" type="datetimeFigureOut">
               <a:rPr lang="en-US" smtClean="0"/>
-              <a:t>3/29/26</a:t>
+              <a:t>4/1/26</a:t>
             </a:fld>
             <a:endParaRPr lang="en-US"/>
           </a:p>
@@ -2262,7 +2262,7 @@
           <a:p>
             <a:fld id="{5BCAD085-E8A6-8845-BD4E-CB4CCA059FC4}" type="datetimeFigureOut">
               <a:rPr lang="en-US" smtClean="0"/>
-              <a:t>3/29/26</a:t>
+              <a:t>4/1/26</a:t>
             </a:fld>
             <a:endParaRPr lang="en-US"/>
           </a:p>
@@ -2514,7 +2514,7 @@
           <a:p>
             <a:fld id="{5BCAD085-E8A6-8845-BD4E-CB4CCA059FC4}" type="datetimeFigureOut">
               <a:rPr lang="en-US" smtClean="0"/>
-              <a:t>3/29/26</a:t>
+              <a:t>4/1/26</a:t>
             </a:fld>
             <a:endParaRPr lang="en-US"/>
           </a:p>
@@ -2725,7 +2725,7 @@
           <a:p>
             <a:fld id="{5BCAD085-E8A6-8845-BD4E-CB4CCA059FC4}" type="datetimeFigureOut">
               <a:rPr lang="en-US" smtClean="0"/>
-              <a:t>3/29/26</a:t>
+              <a:t>4/1/26</a:t>
             </a:fld>
             <a:endParaRPr lang="en-US"/>
           </a:p>
@@ -4538,7 +4538,7 @@
         <p:spPr>
           <a:xfrm>
             <a:off x="493776" y="2011680"/>
-            <a:ext cx="5321808" cy="621792"/>
+            <a:ext cx="5321808" cy="246221"/>
           </a:xfrm>
           <a:prstGeom prst="rect">
             <a:avLst/>
@@ -4553,12 +4553,28 @@
           <a:p>
             <a:pPr algn="l"/>
             <a:r>
-              <a:rPr sz="1000" b="1" i="0">
+              <a:rPr sz="1000" b="1" i="0" dirty="0">
                 <a:solidFill>
                   <a:srgbClr val="B5573A"/>
                 </a:solidFill>
               </a:rPr>
-              <a:t>Model:  Coeff +2.23 · p&lt;0.001 · Strongest predictor overall</a:t>
+              <a:t>Model:  Coeff +2.</a:t>
+            </a:r>
+            <a:r>
+              <a:rPr lang="en-US" sz="1000" b="1" i="0" dirty="0">
+                <a:solidFill>
+                  <a:srgbClr val="B5573A"/>
+                </a:solidFill>
+              </a:rPr>
+              <a:t>14</a:t>
+            </a:r>
+            <a:r>
+              <a:rPr sz="1000" b="1" i="0" dirty="0">
+                <a:solidFill>
+                  <a:srgbClr val="B5573A"/>
+                </a:solidFill>
+              </a:rPr>
+              <a:t> · p&lt;0.001 · Strongest predictor overall</a:t>
             </a:r>
           </a:p>
         </p:txBody>
@@ -4660,7 +4676,7 @@
         <p:spPr>
           <a:xfrm>
             <a:off x="6483096" y="1261872"/>
-            <a:ext cx="5321808" cy="329184"/>
+            <a:ext cx="5321808" cy="276999"/>
           </a:xfrm>
           <a:prstGeom prst="rect">
             <a:avLst/>
@@ -4675,12 +4691,12 @@
           <a:p>
             <a:pPr algn="l"/>
             <a:r>
-              <a:rPr sz="1200" b="1" i="0">
+              <a:rPr sz="1200" b="1" i="0" dirty="0">
                 <a:solidFill>
                   <a:srgbClr val="1B3A4B"/>
                 </a:solidFill>
               </a:rPr>
-              <a:t>Incident Severity Paradox</a:t>
+              <a:t>Incident Severity</a:t>
             </a:r>
           </a:p>
         </p:txBody>
@@ -4772,7 +4788,7 @@
         <p:spPr>
           <a:xfrm>
             <a:off x="6483096" y="2011680"/>
-            <a:ext cx="5321808" cy="621792"/>
+            <a:ext cx="5321808" cy="246221"/>
           </a:xfrm>
           <a:prstGeom prst="rect">
             <a:avLst/>
@@ -4787,12 +4803,44 @@
           <a:p>
             <a:pPr algn="l"/>
             <a:r>
-              <a:rPr sz="1000" b="1" i="0">
+              <a:rPr sz="1000" b="1" i="0" dirty="0">
                 <a:solidFill>
                   <a:srgbClr val="C9A456"/>
                 </a:solidFill>
               </a:rPr>
-              <a:t>Model:  Minor/Trivial/TotalLoss all negative (−1.3 to −1.9)</a:t>
+              <a:t>Model:  Minor/Trivial/Total Loss all negative (−1.3</a:t>
+            </a:r>
+            <a:r>
+              <a:rPr lang="en-US" sz="1000" b="1" i="0" dirty="0">
+                <a:solidFill>
+                  <a:srgbClr val="C9A456"/>
+                </a:solidFill>
+              </a:rPr>
+              <a:t>8</a:t>
+            </a:r>
+            <a:r>
+              <a:rPr sz="1000" b="1" i="0" dirty="0">
+                <a:solidFill>
+                  <a:srgbClr val="C9A456"/>
+                </a:solidFill>
+              </a:rPr>
+              <a:t> to −1.9</a:t>
+            </a:r>
+            <a:r>
+              <a:rPr lang="en-US" sz="1000" b="1" i="0" dirty="0">
+                <a:solidFill>
+                  <a:srgbClr val="C9A456"/>
+                </a:solidFill>
+              </a:rPr>
+              <a:t>0</a:t>
+            </a:r>
+            <a:r>
+              <a:rPr sz="1000" b="1" i="0" dirty="0">
+                <a:solidFill>
+                  <a:srgbClr val="C9A456"/>
+                </a:solidFill>
+              </a:rPr>
+              <a:t>)</a:t>
             </a:r>
           </a:p>
         </p:txBody>
@@ -5006,7 +5054,7 @@
         <p:spPr>
           <a:xfrm>
             <a:off x="493776" y="3749039"/>
-            <a:ext cx="5321808" cy="621792"/>
+            <a:ext cx="5321808" cy="246221"/>
           </a:xfrm>
           <a:prstGeom prst="rect">
             <a:avLst/>
@@ -5021,12 +5069,28 @@
           <a:p>
             <a:pPr algn="l"/>
             <a:r>
-              <a:rPr sz="1000" b="1" i="0">
+              <a:rPr sz="1000" b="1" i="0" dirty="0">
                 <a:solidFill>
                   <a:srgbClr val="4472A8"/>
                 </a:solidFill>
               </a:rPr>
-              <a:t>Model:  Coeff +0.41 · p&lt;0.001 · Staged accident signal</a:t>
+              <a:t>Model:  Coeff +0.4</a:t>
+            </a:r>
+            <a:r>
+              <a:rPr lang="en-US" sz="1000" b="1" i="0" dirty="0">
+                <a:solidFill>
+                  <a:srgbClr val="4472A8"/>
+                </a:solidFill>
+              </a:rPr>
+              <a:t>0</a:t>
+            </a:r>
+            <a:r>
+              <a:rPr sz="1000" b="1" i="0" dirty="0">
+                <a:solidFill>
+                  <a:srgbClr val="4472A8"/>
+                </a:solidFill>
+              </a:rPr>
+              <a:t> · p&lt;0.001 · Staged accident signal</a:t>
             </a:r>
           </a:p>
         </p:txBody>
@@ -5240,7 +5304,7 @@
         <p:spPr>
           <a:xfrm>
             <a:off x="6483096" y="3749039"/>
-            <a:ext cx="5321808" cy="621792"/>
+            <a:ext cx="5321808" cy="246221"/>
           </a:xfrm>
           <a:prstGeom prst="rect">
             <a:avLst/>
@@ -5255,12 +5319,28 @@
           <a:p>
             <a:pPr algn="l"/>
             <a:r>
-              <a:rPr sz="1000" b="1" i="0">
+              <a:rPr sz="1000" b="1" i="0" dirty="0">
                 <a:solidFill>
                   <a:srgbClr val="4A7C59"/>
                 </a:solidFill>
               </a:rPr>
-              <a:t>Model:  Coeff +0.39 · p&lt;0.001 · Fully consistent with EDA</a:t>
+              <a:t>Model:  Coeff +0.</a:t>
+            </a:r>
+            <a:r>
+              <a:rPr lang="en-US" sz="1000" b="1" i="0" dirty="0">
+                <a:solidFill>
+                  <a:srgbClr val="4A7C59"/>
+                </a:solidFill>
+              </a:rPr>
+              <a:t>40</a:t>
+            </a:r>
+            <a:r>
+              <a:rPr sz="1000" b="1" i="0" dirty="0">
+                <a:solidFill>
+                  <a:srgbClr val="4A7C59"/>
+                </a:solidFill>
+              </a:rPr>
+              <a:t> · p&lt;0.001 · Fully consistent with EDA</a:t>
             </a:r>
           </a:p>
         </p:txBody>
@@ -5474,7 +5554,7 @@
         <p:spPr>
           <a:xfrm>
             <a:off x="493776" y="5486400"/>
-            <a:ext cx="5321808" cy="621792"/>
+            <a:ext cx="5321808" cy="246221"/>
           </a:xfrm>
           <a:prstGeom prst="rect">
             <a:avLst/>
@@ -5489,12 +5569,44 @@
           <a:p>
             <a:pPr algn="l"/>
             <a:r>
-              <a:rPr sz="1000" b="1" i="0">
+              <a:rPr sz="1000" b="1" i="0" dirty="0">
                 <a:solidFill>
                   <a:srgbClr val="1B3A4B"/>
                 </a:solidFill>
               </a:rPr>
-              <a:t>Model:  Coeff +0.31 · p=0.004 · Organised staging confirmed</a:t>
+              <a:t>Model:  Coeff +0.3</a:t>
+            </a:r>
+            <a:r>
+              <a:rPr lang="en-US" sz="1000" b="1" i="0" dirty="0">
+                <a:solidFill>
+                  <a:srgbClr val="1B3A4B"/>
+                </a:solidFill>
+              </a:rPr>
+              <a:t>2</a:t>
+            </a:r>
+            <a:r>
+              <a:rPr sz="1000" b="1" i="0" dirty="0">
+                <a:solidFill>
+                  <a:srgbClr val="1B3A4B"/>
+                </a:solidFill>
+              </a:rPr>
+              <a:t> · p=0.00</a:t>
+            </a:r>
+            <a:r>
+              <a:rPr lang="en-US" sz="1000" b="1" i="0" dirty="0">
+                <a:solidFill>
+                  <a:srgbClr val="1B3A4B"/>
+                </a:solidFill>
+              </a:rPr>
+              <a:t>2</a:t>
+            </a:r>
+            <a:r>
+              <a:rPr sz="1000" b="1" i="0" dirty="0">
+                <a:solidFill>
+                  <a:srgbClr val="1B3A4B"/>
+                </a:solidFill>
+              </a:rPr>
+              <a:t> · Organized staging confirmed</a:t>
             </a:r>
           </a:p>
         </p:txBody>
@@ -5708,7 +5820,7 @@
         <p:spPr>
           <a:xfrm>
             <a:off x="6483096" y="5486400"/>
-            <a:ext cx="5321808" cy="621792"/>
+            <a:ext cx="5321808" cy="246221"/>
           </a:xfrm>
           <a:prstGeom prst="rect">
             <a:avLst/>
@@ -5723,12 +5835,28 @@
           <a:p>
             <a:pPr algn="l"/>
             <a:r>
-              <a:rPr sz="1000" b="1" i="0">
+              <a:rPr sz="1000" b="1" i="0" dirty="0">
                 <a:solidFill>
                   <a:srgbClr val="7B4F28"/>
                 </a:solidFill>
               </a:rPr>
-              <a:t>Model:  Coeff +0.46 · p&lt;0.001 · Premium policy fraud magnet</a:t>
+              <a:t>Model:  Coeff +0.4</a:t>
+            </a:r>
+            <a:r>
+              <a:rPr lang="en-US" sz="1000" b="1" i="0" dirty="0">
+                <a:solidFill>
+                  <a:srgbClr val="7B4F28"/>
+                </a:solidFill>
+              </a:rPr>
+              <a:t>7</a:t>
+            </a:r>
+            <a:r>
+              <a:rPr sz="1000" b="1" i="0" dirty="0">
+                <a:solidFill>
+                  <a:srgbClr val="7B4F28"/>
+                </a:solidFill>
+              </a:rPr>
+              <a:t> · p&lt;0.001 · Premium policy fraud magnet</a:t>
             </a:r>
           </a:p>
         </p:txBody>
@@ -5766,7 +5894,7 @@
         </p:nvSpPr>
         <p:spPr>
           <a:xfrm>
-            <a:off x="0" y="0"/>
+            <a:off x="-127" y="118872"/>
             <a:ext cx="12188952" cy="6858000"/>
           </a:xfrm>
           <a:prstGeom prst="rect">
@@ -7062,13 +7190,13 @@
       </p:sp>
       <p:sp>
         <p:nvSpPr>
-          <p:cNvPr id="35" name="Rectangle 34"/>
+          <p:cNvPr id="37" name="Rectangle 36"/>
           <p:cNvSpPr/>
           <p:nvPr/>
         </p:nvSpPr>
         <p:spPr>
           <a:xfrm>
-            <a:off x="402336" y="4315968"/>
+            <a:off x="420497" y="4398264"/>
             <a:ext cx="164592" cy="164592"/>
           </a:xfrm>
           <a:prstGeom prst="rect">
@@ -7106,13 +7234,13 @@
       </p:sp>
       <p:sp>
         <p:nvSpPr>
-          <p:cNvPr id="36" name="TextBox 35"/>
-          <p:cNvSpPr txBox="1"/>
-          <p:nvPr/>
-        </p:nvSpPr>
-        <p:spPr>
-          <a:xfrm>
-            <a:off x="640080" y="4297680"/>
+          <p:cNvPr id="38" name="TextBox 37"/>
+          <p:cNvSpPr txBox="1"/>
+          <p:nvPr/>
+        </p:nvSpPr>
+        <p:spPr>
+          <a:xfrm>
+            <a:off x="658241" y="4379976"/>
             <a:ext cx="5138928" cy="384048"/>
           </a:xfrm>
           <a:prstGeom prst="rect">
@@ -7133,20 +7261,20 @@
                   <a:srgbClr val="2C2C2C"/>
                 </a:solidFill>
               </a:rPr>
-              <a:t>Deploy Special Investigation Units (SIU) in OH &amp; PA</a:t>
-            </a:r>
-          </a:p>
-        </p:txBody>
-      </p:sp>
-      <p:sp>
-        <p:nvSpPr>
-          <p:cNvPr id="37" name="Rectangle 36"/>
+              <a:t>Collaborate with local law enforcement in hotspot cities</a:t>
+            </a:r>
+          </a:p>
+        </p:txBody>
+      </p:sp>
+      <p:sp>
+        <p:nvSpPr>
+          <p:cNvPr id="39" name="Rectangle 38"/>
           <p:cNvSpPr/>
           <p:nvPr/>
         </p:nvSpPr>
         <p:spPr>
           <a:xfrm>
-            <a:off x="402336" y="4754880"/>
+            <a:off x="420497" y="4887976"/>
             <a:ext cx="164592" cy="164592"/>
           </a:xfrm>
           <a:prstGeom prst="rect">
@@ -7184,13 +7312,13 @@
       </p:sp>
       <p:sp>
         <p:nvSpPr>
-          <p:cNvPr id="38" name="TextBox 37"/>
-          <p:cNvSpPr txBox="1"/>
-          <p:nvPr/>
-        </p:nvSpPr>
-        <p:spPr>
-          <a:xfrm>
-            <a:off x="640080" y="4736592"/>
+          <p:cNvPr id="40" name="TextBox 39"/>
+          <p:cNvSpPr txBox="1"/>
+          <p:nvPr/>
+        </p:nvSpPr>
+        <p:spPr>
+          <a:xfrm>
+            <a:off x="658241" y="4869688"/>
             <a:ext cx="5138928" cy="384048"/>
           </a:xfrm>
           <a:prstGeom prst="rect">
@@ -7206,25 +7334,25 @@
           <a:p>
             <a:pPr algn="l"/>
             <a:r>
-              <a:rPr sz="1000" b="0" i="0">
+              <a:rPr sz="1000" b="0" i="0" dirty="0">
                 <a:solidFill>
                   <a:srgbClr val="2C2C2C"/>
                 </a:solidFill>
               </a:rPr>
-              <a:t>Collaborate with local law enforcement in hotspot cities</a:t>
-            </a:r>
-          </a:p>
-        </p:txBody>
-      </p:sp>
-      <p:sp>
-        <p:nvSpPr>
-          <p:cNvPr id="39" name="Rectangle 38"/>
+              <a:t>Run targeted fraud-awareness campaigns in high-risk states</a:t>
+            </a:r>
+          </a:p>
+        </p:txBody>
+      </p:sp>
+      <p:sp>
+        <p:nvSpPr>
+          <p:cNvPr id="41" name="Rectangle 40"/>
           <p:cNvSpPr/>
           <p:nvPr/>
         </p:nvSpPr>
         <p:spPr>
           <a:xfrm>
-            <a:off x="402336" y="5193792"/>
+            <a:off x="420497" y="5358384"/>
             <a:ext cx="164592" cy="164592"/>
           </a:xfrm>
           <a:prstGeom prst="rect">
@@ -7262,13 +7390,13 @@
       </p:sp>
       <p:sp>
         <p:nvSpPr>
-          <p:cNvPr id="40" name="TextBox 39"/>
-          <p:cNvSpPr txBox="1"/>
-          <p:nvPr/>
-        </p:nvSpPr>
-        <p:spPr>
-          <a:xfrm>
-            <a:off x="640080" y="5175504"/>
+          <p:cNvPr id="42" name="TextBox 41"/>
+          <p:cNvSpPr txBox="1"/>
+          <p:nvPr/>
+        </p:nvSpPr>
+        <p:spPr>
+          <a:xfrm>
+            <a:off x="658241" y="5340096"/>
             <a:ext cx="5138928" cy="384048"/>
           </a:xfrm>
           <a:prstGeom prst="rect">
@@ -7284,524 +7412,12 @@
           <a:p>
             <a:pPr algn="l"/>
             <a:r>
-              <a:rPr sz="1000" b="0" i="0">
+              <a:rPr sz="1000" b="0" i="0" dirty="0">
                 <a:solidFill>
                   <a:srgbClr val="2C2C2C"/>
                 </a:solidFill>
               </a:rPr>
-              <a:t>Run targeted fraud-awareness campaigns in high-risk states</a:t>
-            </a:r>
-          </a:p>
-        </p:txBody>
-      </p:sp>
-      <p:sp>
-        <p:nvSpPr>
-          <p:cNvPr id="41" name="Rectangle 40"/>
-          <p:cNvSpPr/>
-          <p:nvPr/>
-        </p:nvSpPr>
-        <p:spPr>
-          <a:xfrm>
-            <a:off x="402336" y="5632704"/>
-            <a:ext cx="164592" cy="164592"/>
-          </a:xfrm>
-          <a:prstGeom prst="rect">
-            <a:avLst/>
-          </a:prstGeom>
-          <a:solidFill>
-            <a:srgbClr val="C9A456"/>
-          </a:solidFill>
-          <a:ln>
-            <a:noFill/>
-          </a:ln>
-        </p:spPr>
-        <p:style>
-          <a:lnRef idx="1">
-            <a:schemeClr val="accent1"/>
-          </a:lnRef>
-          <a:fillRef idx="3">
-            <a:schemeClr val="accent1"/>
-          </a:fillRef>
-          <a:effectRef idx="2">
-            <a:schemeClr val="accent1"/>
-          </a:effectRef>
-          <a:fontRef idx="minor">
-            <a:schemeClr val="lt1"/>
-          </a:fontRef>
-        </p:style>
-        <p:txBody>
-          <a:bodyPr rtlCol="0" anchor="ctr"/>
-          <a:lstStyle/>
-          <a:p>
-            <a:pPr algn="ctr"/>
-            <a:endParaRPr/>
-          </a:p>
-        </p:txBody>
-      </p:sp>
-      <p:sp>
-        <p:nvSpPr>
-          <p:cNvPr id="42" name="TextBox 41"/>
-          <p:cNvSpPr txBox="1"/>
-          <p:nvPr/>
-        </p:nvSpPr>
-        <p:spPr>
-          <a:xfrm>
-            <a:off x="640080" y="5614416"/>
-            <a:ext cx="5138928" cy="384048"/>
-          </a:xfrm>
-          <a:prstGeom prst="rect">
-            <a:avLst/>
-          </a:prstGeom>
-          <a:noFill/>
-        </p:spPr>
-        <p:txBody>
-          <a:bodyPr wrap="square">
-            <a:spAutoFit/>
-          </a:bodyPr>
-          <a:lstStyle/>
-          <a:p>
-            <a:pPr algn="l"/>
-            <a:r>
-              <a:rPr sz="1000" b="0" i="0">
-                <a:solidFill>
-                  <a:srgbClr val="2C2C2C"/>
-                </a:solidFill>
-              </a:rPr>
               <a:t>Monitor seasonal claim-spike patterns at city level</a:t>
-            </a:r>
-          </a:p>
-        </p:txBody>
-      </p:sp>
-      <p:sp>
-        <p:nvSpPr>
-          <p:cNvPr id="43" name="Rectangle 42"/>
-          <p:cNvSpPr/>
-          <p:nvPr/>
-        </p:nvSpPr>
-        <p:spPr>
-          <a:xfrm>
-            <a:off x="6245352" y="3803904"/>
-            <a:ext cx="5687568" cy="2423160"/>
-          </a:xfrm>
-          <a:prstGeom prst="rect">
-            <a:avLst/>
-          </a:prstGeom>
-          <a:solidFill>
-            <a:srgbClr val="FFFFFF"/>
-          </a:solidFill>
-          <a:ln>
-            <a:noFill/>
-          </a:ln>
-        </p:spPr>
-        <p:style>
-          <a:lnRef idx="1">
-            <a:schemeClr val="accent1"/>
-          </a:lnRef>
-          <a:fillRef idx="3">
-            <a:schemeClr val="accent1"/>
-          </a:fillRef>
-          <a:effectRef idx="2">
-            <a:schemeClr val="accent1"/>
-          </a:effectRef>
-          <a:fontRef idx="minor">
-            <a:schemeClr val="lt1"/>
-          </a:fontRef>
-        </p:style>
-        <p:txBody>
-          <a:bodyPr rtlCol="0" anchor="ctr"/>
-          <a:lstStyle/>
-          <a:p>
-            <a:pPr algn="ctr"/>
-            <a:endParaRPr/>
-          </a:p>
-        </p:txBody>
-      </p:sp>
-      <p:sp>
-        <p:nvSpPr>
-          <p:cNvPr id="44" name="Rectangle 43"/>
-          <p:cNvSpPr/>
-          <p:nvPr/>
-        </p:nvSpPr>
-        <p:spPr>
-          <a:xfrm>
-            <a:off x="6245352" y="3803904"/>
-            <a:ext cx="5687568" cy="384048"/>
-          </a:xfrm>
-          <a:prstGeom prst="rect">
-            <a:avLst/>
-          </a:prstGeom>
-          <a:solidFill>
-            <a:srgbClr val="4A7C59"/>
-          </a:solidFill>
-          <a:ln>
-            <a:noFill/>
-          </a:ln>
-        </p:spPr>
-        <p:style>
-          <a:lnRef idx="1">
-            <a:schemeClr val="accent1"/>
-          </a:lnRef>
-          <a:fillRef idx="3">
-            <a:schemeClr val="accent1"/>
-          </a:fillRef>
-          <a:effectRef idx="2">
-            <a:schemeClr val="accent1"/>
-          </a:effectRef>
-          <a:fontRef idx="minor">
-            <a:schemeClr val="lt1"/>
-          </a:fontRef>
-        </p:style>
-        <p:txBody>
-          <a:bodyPr rtlCol="0" anchor="ctr"/>
-          <a:lstStyle/>
-          <a:p>
-            <a:pPr algn="ctr"/>
-            <a:endParaRPr/>
-          </a:p>
-        </p:txBody>
-      </p:sp>
-      <p:sp>
-        <p:nvSpPr>
-          <p:cNvPr id="45" name="TextBox 44"/>
-          <p:cNvSpPr txBox="1"/>
-          <p:nvPr/>
-        </p:nvSpPr>
-        <p:spPr>
-          <a:xfrm>
-            <a:off x="6391656" y="3867912"/>
-            <a:ext cx="5376672" cy="274320"/>
-          </a:xfrm>
-          <a:prstGeom prst="rect">
-            <a:avLst/>
-          </a:prstGeom>
-          <a:noFill/>
-        </p:spPr>
-        <p:txBody>
-          <a:bodyPr wrap="square">
-            <a:spAutoFit/>
-          </a:bodyPr>
-          <a:lstStyle/>
-          <a:p>
-            <a:pPr algn="l"/>
-            <a:r>
-              <a:rPr sz="1200" b="1" i="0">
-                <a:solidFill>
-                  <a:srgbClr val="FFFFFF"/>
-                </a:solidFill>
-              </a:rPr>
-              <a:t>Technology &amp; Data</a:t>
-            </a:r>
-          </a:p>
-        </p:txBody>
-      </p:sp>
-      <p:sp>
-        <p:nvSpPr>
-          <p:cNvPr id="46" name="Rectangle 45"/>
-          <p:cNvSpPr/>
-          <p:nvPr/>
-        </p:nvSpPr>
-        <p:spPr>
-          <a:xfrm>
-            <a:off x="6391656" y="4315968"/>
-            <a:ext cx="164592" cy="164592"/>
-          </a:xfrm>
-          <a:prstGeom prst="rect">
-            <a:avLst/>
-          </a:prstGeom>
-          <a:solidFill>
-            <a:srgbClr val="4A7C59"/>
-          </a:solidFill>
-          <a:ln>
-            <a:noFill/>
-          </a:ln>
-        </p:spPr>
-        <p:style>
-          <a:lnRef idx="1">
-            <a:schemeClr val="accent1"/>
-          </a:lnRef>
-          <a:fillRef idx="3">
-            <a:schemeClr val="accent1"/>
-          </a:fillRef>
-          <a:effectRef idx="2">
-            <a:schemeClr val="accent1"/>
-          </a:effectRef>
-          <a:fontRef idx="minor">
-            <a:schemeClr val="lt1"/>
-          </a:fontRef>
-        </p:style>
-        <p:txBody>
-          <a:bodyPr rtlCol="0" anchor="ctr"/>
-          <a:lstStyle/>
-          <a:p>
-            <a:pPr algn="ctr"/>
-            <a:endParaRPr/>
-          </a:p>
-        </p:txBody>
-      </p:sp>
-      <p:sp>
-        <p:nvSpPr>
-          <p:cNvPr id="47" name="TextBox 46"/>
-          <p:cNvSpPr txBox="1"/>
-          <p:nvPr/>
-        </p:nvSpPr>
-        <p:spPr>
-          <a:xfrm>
-            <a:off x="6629400" y="4297680"/>
-            <a:ext cx="5138928" cy="384048"/>
-          </a:xfrm>
-          <a:prstGeom prst="rect">
-            <a:avLst/>
-          </a:prstGeom>
-          <a:noFill/>
-        </p:spPr>
-        <p:txBody>
-          <a:bodyPr wrap="square">
-            <a:spAutoFit/>
-          </a:bodyPr>
-          <a:lstStyle/>
-          <a:p>
-            <a:pPr algn="l"/>
-            <a:r>
-              <a:rPr sz="1000" b="0" i="0">
-                <a:solidFill>
-                  <a:srgbClr val="2C2C2C"/>
-                </a:solidFill>
-              </a:rPr>
-              <a:t>Deploy Tuned Random Forest in production (84.67% accuracy)</a:t>
-            </a:r>
-          </a:p>
-        </p:txBody>
-      </p:sp>
-      <p:sp>
-        <p:nvSpPr>
-          <p:cNvPr id="48" name="Rectangle 47"/>
-          <p:cNvSpPr/>
-          <p:nvPr/>
-        </p:nvSpPr>
-        <p:spPr>
-          <a:xfrm>
-            <a:off x="6391656" y="4754880"/>
-            <a:ext cx="164592" cy="164592"/>
-          </a:xfrm>
-          <a:prstGeom prst="rect">
-            <a:avLst/>
-          </a:prstGeom>
-          <a:solidFill>
-            <a:srgbClr val="4A7C59"/>
-          </a:solidFill>
-          <a:ln>
-            <a:noFill/>
-          </a:ln>
-        </p:spPr>
-        <p:style>
-          <a:lnRef idx="1">
-            <a:schemeClr val="accent1"/>
-          </a:lnRef>
-          <a:fillRef idx="3">
-            <a:schemeClr val="accent1"/>
-          </a:fillRef>
-          <a:effectRef idx="2">
-            <a:schemeClr val="accent1"/>
-          </a:effectRef>
-          <a:fontRef idx="minor">
-            <a:schemeClr val="lt1"/>
-          </a:fontRef>
-        </p:style>
-        <p:txBody>
-          <a:bodyPr rtlCol="0" anchor="ctr"/>
-          <a:lstStyle/>
-          <a:p>
-            <a:pPr algn="ctr"/>
-            <a:endParaRPr/>
-          </a:p>
-        </p:txBody>
-      </p:sp>
-      <p:sp>
-        <p:nvSpPr>
-          <p:cNvPr id="49" name="TextBox 48"/>
-          <p:cNvSpPr txBox="1"/>
-          <p:nvPr/>
-        </p:nvSpPr>
-        <p:spPr>
-          <a:xfrm>
-            <a:off x="6629400" y="4736592"/>
-            <a:ext cx="5138928" cy="384048"/>
-          </a:xfrm>
-          <a:prstGeom prst="rect">
-            <a:avLst/>
-          </a:prstGeom>
-          <a:noFill/>
-        </p:spPr>
-        <p:txBody>
-          <a:bodyPr wrap="square">
-            <a:spAutoFit/>
-          </a:bodyPr>
-          <a:lstStyle/>
-          <a:p>
-            <a:pPr algn="l"/>
-            <a:r>
-              <a:rPr sz="1000" b="0" i="0">
-                <a:solidFill>
-                  <a:srgbClr val="2C2C2C"/>
-                </a:solidFill>
-              </a:rPr>
-              <a:t>Implement real-time scoring pipeline at claim intake</a:t>
-            </a:r>
-          </a:p>
-        </p:txBody>
-      </p:sp>
-      <p:sp>
-        <p:nvSpPr>
-          <p:cNvPr id="50" name="Rectangle 49"/>
-          <p:cNvSpPr/>
-          <p:nvPr/>
-        </p:nvSpPr>
-        <p:spPr>
-          <a:xfrm>
-            <a:off x="6391656" y="5193792"/>
-            <a:ext cx="164592" cy="164592"/>
-          </a:xfrm>
-          <a:prstGeom prst="rect">
-            <a:avLst/>
-          </a:prstGeom>
-          <a:solidFill>
-            <a:srgbClr val="4A7C59"/>
-          </a:solidFill>
-          <a:ln>
-            <a:noFill/>
-          </a:ln>
-        </p:spPr>
-        <p:style>
-          <a:lnRef idx="1">
-            <a:schemeClr val="accent1"/>
-          </a:lnRef>
-          <a:fillRef idx="3">
-            <a:schemeClr val="accent1"/>
-          </a:fillRef>
-          <a:effectRef idx="2">
-            <a:schemeClr val="accent1"/>
-          </a:effectRef>
-          <a:fontRef idx="minor">
-            <a:schemeClr val="lt1"/>
-          </a:fontRef>
-        </p:style>
-        <p:txBody>
-          <a:bodyPr rtlCol="0" anchor="ctr"/>
-          <a:lstStyle/>
-          <a:p>
-            <a:pPr algn="ctr"/>
-            <a:endParaRPr/>
-          </a:p>
-        </p:txBody>
-      </p:sp>
-      <p:sp>
-        <p:nvSpPr>
-          <p:cNvPr id="51" name="TextBox 50"/>
-          <p:cNvSpPr txBox="1"/>
-          <p:nvPr/>
-        </p:nvSpPr>
-        <p:spPr>
-          <a:xfrm>
-            <a:off x="6629400" y="5175504"/>
-            <a:ext cx="5138928" cy="384048"/>
-          </a:xfrm>
-          <a:prstGeom prst="rect">
-            <a:avLst/>
-          </a:prstGeom>
-          <a:noFill/>
-        </p:spPr>
-        <p:txBody>
-          <a:bodyPr wrap="square">
-            <a:spAutoFit/>
-          </a:bodyPr>
-          <a:lstStyle/>
-          <a:p>
-            <a:pPr algn="l"/>
-            <a:r>
-              <a:rPr sz="1000" b="0" i="0">
-                <a:solidFill>
-                  <a:srgbClr val="2C2C2C"/>
-                </a:solidFill>
-              </a:rPr>
-              <a:t>Enrich data: lifestyle signals, telematics, social patterns</a:t>
-            </a:r>
-          </a:p>
-        </p:txBody>
-      </p:sp>
-      <p:sp>
-        <p:nvSpPr>
-          <p:cNvPr id="52" name="Rectangle 51"/>
-          <p:cNvSpPr/>
-          <p:nvPr/>
-        </p:nvSpPr>
-        <p:spPr>
-          <a:xfrm>
-            <a:off x="6391656" y="5632704"/>
-            <a:ext cx="164592" cy="164592"/>
-          </a:xfrm>
-          <a:prstGeom prst="rect">
-            <a:avLst/>
-          </a:prstGeom>
-          <a:solidFill>
-            <a:srgbClr val="4A7C59"/>
-          </a:solidFill>
-          <a:ln>
-            <a:noFill/>
-          </a:ln>
-        </p:spPr>
-        <p:style>
-          <a:lnRef idx="1">
-            <a:schemeClr val="accent1"/>
-          </a:lnRef>
-          <a:fillRef idx="3">
-            <a:schemeClr val="accent1"/>
-          </a:fillRef>
-          <a:effectRef idx="2">
-            <a:schemeClr val="accent1"/>
-          </a:effectRef>
-          <a:fontRef idx="minor">
-            <a:schemeClr val="lt1"/>
-          </a:fontRef>
-        </p:style>
-        <p:txBody>
-          <a:bodyPr rtlCol="0" anchor="ctr"/>
-          <a:lstStyle/>
-          <a:p>
-            <a:pPr algn="ctr"/>
-            <a:endParaRPr/>
-          </a:p>
-        </p:txBody>
-      </p:sp>
-      <p:sp>
-        <p:nvSpPr>
-          <p:cNvPr id="53" name="TextBox 52"/>
-          <p:cNvSpPr txBox="1"/>
-          <p:nvPr/>
-        </p:nvSpPr>
-        <p:spPr>
-          <a:xfrm>
-            <a:off x="6629400" y="5614416"/>
-            <a:ext cx="5138928" cy="384048"/>
-          </a:xfrm>
-          <a:prstGeom prst="rect">
-            <a:avLst/>
-          </a:prstGeom>
-          <a:noFill/>
-        </p:spPr>
-        <p:txBody>
-          <a:bodyPr wrap="square">
-            <a:spAutoFit/>
-          </a:bodyPr>
-          <a:lstStyle/>
-          <a:p>
-            <a:pPr algn="l"/>
-            <a:r>
-              <a:rPr sz="1000" b="0" i="0">
-                <a:solidFill>
-                  <a:srgbClr val="2C2C2C"/>
-                </a:solidFill>
-              </a:rPr>
-              <a:t>Retrain model quarterly to track evolving fraud patterns</a:t>
             </a:r>
           </a:p>
         </p:txBody>
@@ -14995,7 +14611,7 @@
         </p:nvSpPr>
         <p:spPr>
           <a:xfrm>
-            <a:off x="0" y="0"/>
+            <a:off x="-13716" y="118872"/>
             <a:ext cx="12188952" cy="6858000"/>
           </a:xfrm>
           <a:prstGeom prst="rect">
@@ -15600,27 +15216,43 @@
         <p:spPr>
           <a:xfrm>
             <a:off x="2816351" y="1609344"/>
-            <a:ext cx="1920240" cy="292608"/>
-          </a:xfrm>
-          <a:prstGeom prst="rect">
-            <a:avLst/>
-          </a:prstGeom>
-          <a:noFill/>
-        </p:spPr>
-        <p:txBody>
-          <a:bodyPr wrap="square">
-            <a:spAutoFit/>
-          </a:bodyPr>
-          <a:lstStyle/>
-          <a:p>
-            <a:pPr algn="ctr"/>
-            <a:r>
-              <a:rPr sz="1050" b="0" i="0">
+            <a:ext cx="1920240" cy="253916"/>
+          </a:xfrm>
+          <a:prstGeom prst="rect">
+            <a:avLst/>
+          </a:prstGeom>
+          <a:noFill/>
+        </p:spPr>
+        <p:txBody>
+          <a:bodyPr wrap="square">
+            <a:spAutoFit/>
+          </a:bodyPr>
+          <a:lstStyle/>
+          <a:p>
+            <a:pPr algn="ctr"/>
+            <a:r>
+              <a:rPr sz="1050" b="0" i="0" dirty="0">
                 <a:solidFill>
                   <a:srgbClr val="2C2C2C"/>
                 </a:solidFill>
               </a:rPr>
-              <a:t>88.19%</a:t>
+              <a:t>8</a:t>
+            </a:r>
+            <a:r>
+              <a:rPr lang="en-US" sz="1050" b="0" i="0" dirty="0">
+                <a:solidFill>
+                  <a:srgbClr val="2C2C2C"/>
+                </a:solidFill>
+              </a:rPr>
+              <a:t>7.62</a:t>
+            </a:r>
+            <a:r>
+              <a:rPr sz="1050" b="0" i="0" dirty="0">
+                <a:solidFill>
+                  <a:srgbClr val="2C2C2C"/>
+                </a:solidFill>
+              </a:rPr>
+              <a:t>%</a:t>
             </a:r>
           </a:p>
         </p:txBody>
@@ -15814,27 +15446,35 @@
         <p:spPr>
           <a:xfrm>
             <a:off x="2816351" y="2039111"/>
-            <a:ext cx="1920240" cy="292608"/>
-          </a:xfrm>
-          <a:prstGeom prst="rect">
-            <a:avLst/>
-          </a:prstGeom>
-          <a:noFill/>
-        </p:spPr>
-        <p:txBody>
-          <a:bodyPr wrap="square">
-            <a:spAutoFit/>
-          </a:bodyPr>
-          <a:lstStyle/>
-          <a:p>
-            <a:pPr algn="ctr"/>
-            <a:r>
-              <a:rPr sz="1050" b="0" i="0">
+            <a:ext cx="1920240" cy="253916"/>
+          </a:xfrm>
+          <a:prstGeom prst="rect">
+            <a:avLst/>
+          </a:prstGeom>
+          <a:noFill/>
+        </p:spPr>
+        <p:txBody>
+          <a:bodyPr wrap="square">
+            <a:spAutoFit/>
+          </a:bodyPr>
+          <a:lstStyle/>
+          <a:p>
+            <a:pPr algn="ctr"/>
+            <a:r>
+              <a:rPr lang="en-US" sz="1050" b="0" i="0" dirty="0">
                 <a:solidFill>
                   <a:srgbClr val="2C2C2C"/>
                 </a:solidFill>
               </a:rPr>
-              <a:t>90.48%</a:t>
+              <a:t>88.57</a:t>
+            </a:r>
+            <a:r>
+              <a:rPr sz="1050" b="0" i="0" dirty="0">
+                <a:solidFill>
+                  <a:srgbClr val="2C2C2C"/>
+                </a:solidFill>
+              </a:rPr>
+              <a:t>%</a:t>
             </a:r>
           </a:p>
         </p:txBody>
@@ -16028,27 +15668,35 @@
         <p:spPr>
           <a:xfrm>
             <a:off x="2816351" y="2468879"/>
-            <a:ext cx="1920240" cy="292608"/>
-          </a:xfrm>
-          <a:prstGeom prst="rect">
-            <a:avLst/>
-          </a:prstGeom>
-          <a:noFill/>
-        </p:spPr>
-        <p:txBody>
-          <a:bodyPr wrap="square">
-            <a:spAutoFit/>
-          </a:bodyPr>
-          <a:lstStyle/>
-          <a:p>
-            <a:pPr algn="ctr"/>
-            <a:r>
-              <a:rPr sz="1050" b="0" i="0">
+            <a:ext cx="1920240" cy="253916"/>
+          </a:xfrm>
+          <a:prstGeom prst="rect">
+            <a:avLst/>
+          </a:prstGeom>
+          <a:noFill/>
+        </p:spPr>
+        <p:txBody>
+          <a:bodyPr wrap="square">
+            <a:spAutoFit/>
+          </a:bodyPr>
+          <a:lstStyle/>
+          <a:p>
+            <a:pPr algn="ctr"/>
+            <a:r>
+              <a:rPr lang="en-US" sz="1050" b="0" i="0" dirty="0">
                 <a:solidFill>
                   <a:srgbClr val="2C2C2C"/>
                 </a:solidFill>
               </a:rPr>
-              <a:t>85.90%</a:t>
+              <a:t>86.67</a:t>
+            </a:r>
+            <a:r>
+              <a:rPr sz="1050" b="0" i="0" dirty="0">
+                <a:solidFill>
+                  <a:srgbClr val="2C2C2C"/>
+                </a:solidFill>
+              </a:rPr>
+              <a:t>%</a:t>
             </a:r>
           </a:p>
         </p:txBody>
@@ -16223,7 +15871,7 @@
           <a:p>
             <a:pPr algn="l"/>
             <a:r>
-              <a:rPr sz="1050" b="1" i="0">
+              <a:rPr sz="1050" b="1" i="0" dirty="0">
                 <a:solidFill>
                   <a:srgbClr val="1B3A4B"/>
                 </a:solidFill>
@@ -16242,27 +15890,43 @@
         <p:spPr>
           <a:xfrm>
             <a:off x="2816351" y="2898648"/>
-            <a:ext cx="1920240" cy="292608"/>
-          </a:xfrm>
-          <a:prstGeom prst="rect">
-            <a:avLst/>
-          </a:prstGeom>
-          <a:noFill/>
-        </p:spPr>
-        <p:txBody>
-          <a:bodyPr wrap="square">
-            <a:spAutoFit/>
-          </a:bodyPr>
-          <a:lstStyle/>
-          <a:p>
-            <a:pPr algn="ctr"/>
-            <a:r>
-              <a:rPr sz="1050" b="0" i="0">
+            <a:ext cx="1920240" cy="253916"/>
+          </a:xfrm>
+          <a:prstGeom prst="rect">
+            <a:avLst/>
+          </a:prstGeom>
+          <a:noFill/>
+        </p:spPr>
+        <p:txBody>
+          <a:bodyPr wrap="square">
+            <a:spAutoFit/>
+          </a:bodyPr>
+          <a:lstStyle/>
+          <a:p>
+            <a:pPr algn="ctr"/>
+            <a:r>
+              <a:rPr sz="1050" b="0" i="0" dirty="0">
                 <a:solidFill>
                   <a:srgbClr val="2C2C2C"/>
                 </a:solidFill>
               </a:rPr>
-              <a:t>86.52%</a:t>
+              <a:t>86.</a:t>
+            </a:r>
+            <a:r>
+              <a:rPr lang="en-US" sz="1050" b="0" i="0" dirty="0">
+                <a:solidFill>
+                  <a:srgbClr val="2C2C2C"/>
+                </a:solidFill>
+              </a:rPr>
+              <a:t>92</a:t>
+            </a:r>
+            <a:r>
+              <a:rPr sz="1050" b="0" i="0" dirty="0">
+                <a:solidFill>
+                  <a:srgbClr val="2C2C2C"/>
+                </a:solidFill>
+              </a:rPr>
+              <a:t>%</a:t>
             </a:r>
           </a:p>
         </p:txBody>
@@ -16377,7 +16041,7 @@
         </p:nvSpPr>
         <p:spPr>
           <a:xfrm>
-            <a:off x="256032" y="3246120"/>
+            <a:off x="256032" y="3714667"/>
             <a:ext cx="11676888" cy="429768"/>
           </a:xfrm>
           <a:prstGeom prst="rect">
@@ -16421,7 +16085,7 @@
         </p:nvSpPr>
         <p:spPr>
           <a:xfrm>
-            <a:off x="365760" y="3328415"/>
+            <a:off x="365760" y="3796962"/>
             <a:ext cx="2286000" cy="292608"/>
           </a:xfrm>
           <a:prstGeom prst="rect">
@@ -16455,7 +16119,107 @@
         </p:nvSpPr>
         <p:spPr>
           <a:xfrm>
-            <a:off x="2816351" y="3328415"/>
+            <a:off x="2816351" y="3796962"/>
+            <a:ext cx="1920240" cy="253916"/>
+          </a:xfrm>
+          <a:prstGeom prst="rect">
+            <a:avLst/>
+          </a:prstGeom>
+          <a:noFill/>
+        </p:spPr>
+        <p:txBody>
+          <a:bodyPr wrap="square">
+            <a:spAutoFit/>
+          </a:bodyPr>
+          <a:lstStyle/>
+          <a:p>
+            <a:pPr algn="ctr"/>
+            <a:r>
+              <a:rPr sz="1050" b="0" i="0" dirty="0">
+                <a:solidFill>
+                  <a:srgbClr val="2C2C2C"/>
+                </a:solidFill>
+              </a:rPr>
+              <a:t>8</a:t>
+            </a:r>
+            <a:r>
+              <a:rPr lang="en-US" sz="1050" b="0" i="0" dirty="0">
+                <a:solidFill>
+                  <a:srgbClr val="2C2C2C"/>
+                </a:solidFill>
+              </a:rPr>
+              <a:t>7</a:t>
+            </a:r>
+            <a:r>
+              <a:rPr sz="1050" b="0" i="0" dirty="0">
+                <a:solidFill>
+                  <a:srgbClr val="2C2C2C"/>
+                </a:solidFill>
+              </a:rPr>
+              <a:t>.</a:t>
+            </a:r>
+            <a:r>
+              <a:rPr lang="en-US" sz="1050" b="0" i="0" dirty="0">
+                <a:solidFill>
+                  <a:srgbClr val="2C2C2C"/>
+                </a:solidFill>
+              </a:rPr>
+              <a:t>74</a:t>
+            </a:r>
+            <a:r>
+              <a:rPr sz="1050" b="0" i="0" dirty="0">
+                <a:solidFill>
+                  <a:srgbClr val="2C2C2C"/>
+                </a:solidFill>
+              </a:rPr>
+              <a:t>%</a:t>
+            </a:r>
+          </a:p>
+        </p:txBody>
+      </p:sp>
+      <p:sp>
+        <p:nvSpPr>
+          <p:cNvPr id="43" name="TextBox 42"/>
+          <p:cNvSpPr txBox="1"/>
+          <p:nvPr/>
+        </p:nvSpPr>
+        <p:spPr>
+          <a:xfrm>
+            <a:off x="4873752" y="3796962"/>
+            <a:ext cx="2057400" cy="292608"/>
+          </a:xfrm>
+          <a:prstGeom prst="rect">
+            <a:avLst/>
+          </a:prstGeom>
+          <a:noFill/>
+        </p:spPr>
+        <p:txBody>
+          <a:bodyPr wrap="square">
+            <a:spAutoFit/>
+          </a:bodyPr>
+          <a:lstStyle/>
+          <a:p>
+            <a:pPr algn="ctr"/>
+            <a:r>
+              <a:rPr sz="1050" b="0" i="0">
+                <a:solidFill>
+                  <a:srgbClr val="2C2C2C"/>
+                </a:solidFill>
+              </a:rPr>
+              <a:t>71.01%</a:t>
+            </a:r>
+          </a:p>
+        </p:txBody>
+      </p:sp>
+      <p:sp>
+        <p:nvSpPr>
+          <p:cNvPr id="44" name="TextBox 43"/>
+          <p:cNvSpPr txBox="1"/>
+          <p:nvPr/>
+        </p:nvSpPr>
+        <p:spPr>
+          <a:xfrm>
+            <a:off x="7068312" y="3796962"/>
             <a:ext cx="1920240" cy="292608"/>
           </a:xfrm>
           <a:prstGeom prst="rect">
@@ -16476,74 +16240,6 @@
                   <a:srgbClr val="2C2C2C"/>
                 </a:solidFill>
               </a:rPr>
-              <a:t>88.45%</a:t>
-            </a:r>
-          </a:p>
-        </p:txBody>
-      </p:sp>
-      <p:sp>
-        <p:nvSpPr>
-          <p:cNvPr id="43" name="TextBox 42"/>
-          <p:cNvSpPr txBox="1"/>
-          <p:nvPr/>
-        </p:nvSpPr>
-        <p:spPr>
-          <a:xfrm>
-            <a:off x="4873752" y="3328415"/>
-            <a:ext cx="2057400" cy="292608"/>
-          </a:xfrm>
-          <a:prstGeom prst="rect">
-            <a:avLst/>
-          </a:prstGeom>
-          <a:noFill/>
-        </p:spPr>
-        <p:txBody>
-          <a:bodyPr wrap="square">
-            <a:spAutoFit/>
-          </a:bodyPr>
-          <a:lstStyle/>
-          <a:p>
-            <a:pPr algn="ctr"/>
-            <a:r>
-              <a:rPr sz="1050" b="0" i="0">
-                <a:solidFill>
-                  <a:srgbClr val="2C2C2C"/>
-                </a:solidFill>
-              </a:rPr>
-              <a:t>71.01%</a:t>
-            </a:r>
-          </a:p>
-        </p:txBody>
-      </p:sp>
-      <p:sp>
-        <p:nvSpPr>
-          <p:cNvPr id="44" name="TextBox 43"/>
-          <p:cNvSpPr txBox="1"/>
-          <p:nvPr/>
-        </p:nvSpPr>
-        <p:spPr>
-          <a:xfrm>
-            <a:off x="7068312" y="3328415"/>
-            <a:ext cx="1920240" cy="292608"/>
-          </a:xfrm>
-          <a:prstGeom prst="rect">
-            <a:avLst/>
-          </a:prstGeom>
-          <a:noFill/>
-        </p:spPr>
-        <p:txBody>
-          <a:bodyPr wrap="square">
-            <a:spAutoFit/>
-          </a:bodyPr>
-          <a:lstStyle/>
-          <a:p>
-            <a:pPr algn="ctr"/>
-            <a:r>
-              <a:rPr sz="1050" b="0" i="0">
-                <a:solidFill>
-                  <a:srgbClr val="2C2C2C"/>
-                </a:solidFill>
-              </a:rPr>
               <a:t>93.64%</a:t>
             </a:r>
           </a:p>
@@ -16557,7 +16253,7 @@
         </p:nvSpPr>
         <p:spPr>
           <a:xfrm>
-            <a:off x="9125712" y="3328415"/>
+            <a:off x="9125712" y="3796962"/>
             <a:ext cx="1920240" cy="292608"/>
           </a:xfrm>
           <a:prstGeom prst="rect">
@@ -16591,7 +16287,7 @@
         </p:nvSpPr>
         <p:spPr>
           <a:xfrm>
-            <a:off x="256032" y="3675887"/>
+            <a:off x="256032" y="4154294"/>
             <a:ext cx="11676888" cy="429768"/>
           </a:xfrm>
           <a:prstGeom prst="rect">
@@ -16635,7 +16331,7 @@
         </p:nvSpPr>
         <p:spPr>
           <a:xfrm>
-            <a:off x="365760" y="3758183"/>
+            <a:off x="365760" y="4236590"/>
             <a:ext cx="2286000" cy="292608"/>
           </a:xfrm>
           <a:prstGeom prst="rect">
@@ -16669,7 +16365,7 @@
         </p:nvSpPr>
         <p:spPr>
           <a:xfrm>
-            <a:off x="2816351" y="3758183"/>
+            <a:off x="2816351" y="4236590"/>
             <a:ext cx="1920240" cy="292608"/>
           </a:xfrm>
           <a:prstGeom prst="rect">
@@ -16703,29 +16399,34 @@
         </p:nvSpPr>
         <p:spPr>
           <a:xfrm>
-            <a:off x="4873752" y="3758183"/>
-            <a:ext cx="2057400" cy="292608"/>
-          </a:xfrm>
-          <a:prstGeom prst="rect">
-            <a:avLst/>
-          </a:prstGeom>
-          <a:noFill/>
-        </p:spPr>
-        <p:txBody>
-          <a:bodyPr wrap="square">
-            <a:spAutoFit/>
-          </a:bodyPr>
-          <a:lstStyle/>
-          <a:p>
-            <a:pPr algn="ctr"/>
-            <a:r>
-              <a:rPr sz="1050" b="1" i="0">
+            <a:off x="4873752" y="4236590"/>
+            <a:ext cx="2057400" cy="253916"/>
+          </a:xfrm>
+          <a:prstGeom prst="rect">
+            <a:avLst/>
+          </a:prstGeom>
+          <a:noFill/>
+        </p:spPr>
+        <p:txBody>
+          <a:bodyPr wrap="square">
+            <a:spAutoFit/>
+          </a:bodyPr>
+          <a:lstStyle/>
+          <a:p>
+            <a:pPr algn="ctr"/>
+            <a:r>
+              <a:rPr lang="en-US" sz="1050" b="1" i="0" dirty="0">
                 <a:solidFill>
                   <a:srgbClr val="4A7C59"/>
                 </a:solidFill>
               </a:rPr>
-              <a:t>0.877</a:t>
-            </a:r>
+              <a:t>84.24%</a:t>
+            </a:r>
+            <a:endParaRPr sz="1050" b="1" i="0" dirty="0">
+              <a:solidFill>
+                <a:srgbClr val="4A7C59"/>
+              </a:solidFill>
+            </a:endParaRPr>
           </a:p>
         </p:txBody>
       </p:sp>
@@ -16737,28 +16438,44 @@
         </p:nvSpPr>
         <p:spPr>
           <a:xfrm>
-            <a:off x="7068312" y="3758183"/>
-            <a:ext cx="1920240" cy="292608"/>
-          </a:xfrm>
-          <a:prstGeom prst="rect">
-            <a:avLst/>
-          </a:prstGeom>
-          <a:noFill/>
-        </p:spPr>
-        <p:txBody>
-          <a:bodyPr wrap="square">
-            <a:spAutoFit/>
-          </a:bodyPr>
-          <a:lstStyle/>
-          <a:p>
-            <a:pPr algn="ctr"/>
-            <a:r>
-              <a:rPr sz="1050" b="0" i="0">
+            <a:off x="7068312" y="4236590"/>
+            <a:ext cx="1920240" cy="253916"/>
+          </a:xfrm>
+          <a:prstGeom prst="rect">
+            <a:avLst/>
+          </a:prstGeom>
+          <a:noFill/>
+        </p:spPr>
+        <p:txBody>
+          <a:bodyPr wrap="square">
+            <a:spAutoFit/>
+          </a:bodyPr>
+          <a:lstStyle/>
+          <a:p>
+            <a:pPr algn="ctr"/>
+            <a:r>
+              <a:rPr sz="1050" b="0" i="0" dirty="0">
                 <a:solidFill>
                   <a:srgbClr val="2C2C2C"/>
                 </a:solidFill>
               </a:rPr>
-              <a:t>~95%</a:t>
+              <a:t>9</a:t>
+            </a:r>
+            <a:r>
+              <a:rPr lang="en-US" sz="1050" b="0" i="0" dirty="0">
+                <a:solidFill>
+                  <a:srgbClr val="2C2C2C"/>
+                </a:solidFill>
+              </a:rPr>
+              <a:t>8.91</a:t>
+            </a:r>
+            <a:r>
+              <a:rPr sz="1050" b="0" i="0" dirty="0">
+                <a:solidFill>
+                  <a:srgbClr val="2C2C2C"/>
+                </a:solidFill>
+              </a:rPr>
+              <a:t>%</a:t>
             </a:r>
           </a:p>
         </p:txBody>
@@ -16771,29 +16488,34 @@
         </p:nvSpPr>
         <p:spPr>
           <a:xfrm>
-            <a:off x="9125712" y="3758183"/>
-            <a:ext cx="1920240" cy="292608"/>
-          </a:xfrm>
-          <a:prstGeom prst="rect">
-            <a:avLst/>
-          </a:prstGeom>
-          <a:noFill/>
-        </p:spPr>
-        <p:txBody>
-          <a:bodyPr wrap="square">
-            <a:spAutoFit/>
-          </a:bodyPr>
-          <a:lstStyle/>
-          <a:p>
-            <a:pPr algn="ctr"/>
-            <a:r>
-              <a:rPr sz="1050" b="1" i="0">
+            <a:off x="9125712" y="4236590"/>
+            <a:ext cx="1920240" cy="253916"/>
+          </a:xfrm>
+          <a:prstGeom prst="rect">
+            <a:avLst/>
+          </a:prstGeom>
+          <a:noFill/>
+        </p:spPr>
+        <p:txBody>
+          <a:bodyPr wrap="square">
+            <a:spAutoFit/>
+          </a:bodyPr>
+          <a:lstStyle/>
+          <a:p>
+            <a:pPr algn="ctr"/>
+            <a:r>
+              <a:rPr lang="en-US" sz="1050" b="1" i="0" dirty="0">
                 <a:solidFill>
                   <a:srgbClr val="4A7C59"/>
                 </a:solidFill>
               </a:rPr>
-              <a:t>0.893</a:t>
-            </a:r>
+              <a:t>83.51%</a:t>
+            </a:r>
+            <a:endParaRPr sz="1050" b="1" i="0" dirty="0">
+              <a:solidFill>
+                <a:srgbClr val="4A7C59"/>
+              </a:solidFill>
+            </a:endParaRPr>
           </a:p>
         </p:txBody>
       </p:sp>
@@ -16805,7 +16527,7 @@
         </p:nvSpPr>
         <p:spPr>
           <a:xfrm>
-            <a:off x="256032" y="4160520"/>
+            <a:off x="256032" y="4627369"/>
             <a:ext cx="11676888" cy="420624"/>
           </a:xfrm>
           <a:prstGeom prst="rect">
@@ -16849,7 +16571,7 @@
         </p:nvSpPr>
         <p:spPr>
           <a:xfrm>
-            <a:off x="411480" y="4206240"/>
+            <a:off x="411480" y="4673089"/>
             <a:ext cx="11247120" cy="329184"/>
           </a:xfrm>
           <a:prstGeom prst="rect">
@@ -16865,7 +16587,7 @@
           <a:p>
             <a:pPr algn="ctr"/>
             <a:r>
-              <a:rPr sz="1050" b="1" i="0">
+              <a:rPr sz="1050" b="1" i="0" dirty="0">
                 <a:solidFill>
                   <a:srgbClr val="FFFFFF"/>
                 </a:solidFill>
@@ -16883,7 +16605,7 @@
         </p:nvSpPr>
         <p:spPr>
           <a:xfrm>
-            <a:off x="256032" y="4736592"/>
+            <a:off x="256032" y="5094222"/>
             <a:ext cx="5596128" cy="347472"/>
           </a:xfrm>
           <a:prstGeom prst="rect">
@@ -16927,7 +16649,7 @@
         </p:nvSpPr>
         <p:spPr>
           <a:xfrm>
-            <a:off x="384048" y="4791455"/>
+            <a:off x="356616" y="5116066"/>
             <a:ext cx="5367528" cy="256032"/>
           </a:xfrm>
           <a:prstGeom prst="rect">
@@ -16943,7 +16665,7 @@
           <a:p>
             <a:pPr algn="l"/>
             <a:r>
-              <a:rPr sz="1100" b="1" i="0">
+              <a:rPr sz="1100" b="1" i="0" dirty="0">
                 <a:solidFill>
                   <a:srgbClr val="FFFFFF"/>
                 </a:solidFill>
@@ -16961,8 +16683,8 @@
         </p:nvSpPr>
         <p:spPr>
           <a:xfrm>
-            <a:off x="256032" y="5084064"/>
-            <a:ext cx="5596128" cy="1417320"/>
+            <a:off x="255905" y="5472683"/>
+            <a:ext cx="5596255" cy="1028700"/>
           </a:xfrm>
           <a:prstGeom prst="rect">
             <a:avLst/>
@@ -17005,7 +16727,7 @@
         </p:nvSpPr>
         <p:spPr>
           <a:xfrm>
-            <a:off x="411480" y="5148072"/>
+            <a:off x="388620" y="5565329"/>
             <a:ext cx="5285232" cy="370332"/>
           </a:xfrm>
           <a:prstGeom prst="rect">
@@ -17021,7 +16743,7 @@
           <a:p>
             <a:pPr algn="l"/>
             <a:r>
-              <a:rPr sz="950" b="0" i="0">
+              <a:rPr sz="950" b="0" i="0" dirty="0">
                 <a:solidFill>
                   <a:srgbClr val="2C2C2C"/>
                 </a:solidFill>
@@ -17039,7 +16761,7 @@
         </p:nvSpPr>
         <p:spPr>
           <a:xfrm>
-            <a:off x="411480" y="5472683"/>
+            <a:off x="365760" y="5810228"/>
             <a:ext cx="5285232" cy="370332"/>
           </a:xfrm>
           <a:prstGeom prst="rect">
@@ -17055,7 +16777,7 @@
           <a:p>
             <a:pPr algn="l"/>
             <a:r>
-              <a:rPr sz="950" b="0" i="0">
+              <a:rPr sz="950" b="0" i="0" dirty="0">
                 <a:solidFill>
                   <a:srgbClr val="2C2C2C"/>
                 </a:solidFill>
@@ -17073,7 +16795,7 @@
         </p:nvSpPr>
         <p:spPr>
           <a:xfrm>
-            <a:off x="411480" y="5797296"/>
+            <a:off x="365760" y="6043676"/>
             <a:ext cx="5285232" cy="370332"/>
           </a:xfrm>
           <a:prstGeom prst="rect">
@@ -17089,46 +16811,12 @@
           <a:p>
             <a:pPr algn="l"/>
             <a:r>
-              <a:rPr sz="950" b="0" i="0">
+              <a:rPr sz="950" b="0" i="0" dirty="0">
                 <a:solidFill>
                   <a:srgbClr val="2C2C2C"/>
                 </a:solidFill>
               </a:rPr>
               <a:t>▸  Highly interpretable: coefficients map to business rules</a:t>
-            </a:r>
-          </a:p>
-        </p:txBody>
-      </p:sp>
-      <p:sp>
-        <p:nvSpPr>
-          <p:cNvPr id="60" name="TextBox 59"/>
-          <p:cNvSpPr txBox="1"/>
-          <p:nvPr/>
-        </p:nvSpPr>
-        <p:spPr>
-          <a:xfrm>
-            <a:off x="411480" y="6121908"/>
-            <a:ext cx="5285232" cy="370332"/>
-          </a:xfrm>
-          <a:prstGeom prst="rect">
-            <a:avLst/>
-          </a:prstGeom>
-          <a:noFill/>
-        </p:spPr>
-        <p:txBody>
-          <a:bodyPr wrap="square">
-            <a:spAutoFit/>
-          </a:bodyPr>
-          <a:lstStyle/>
-          <a:p>
-            <a:pPr algn="l"/>
-            <a:r>
-              <a:rPr sz="950" b="0" i="0">
-                <a:solidFill>
-                  <a:srgbClr val="2C2C2C"/>
-                </a:solidFill>
-              </a:rPr>
-              <a:t>▸  Pseudo R² = 0.52 — strong explanatory power</a:t>
             </a:r>
           </a:p>
         </p:txBody>
@@ -17141,7 +16829,7 @@
         </p:nvSpPr>
         <p:spPr>
           <a:xfrm>
-            <a:off x="6080760" y="4736592"/>
+            <a:off x="6080760" y="5060695"/>
             <a:ext cx="5852160" cy="347472"/>
           </a:xfrm>
           <a:prstGeom prst="rect">
@@ -17185,7 +16873,7 @@
         </p:nvSpPr>
         <p:spPr>
           <a:xfrm>
-            <a:off x="6208776" y="4791455"/>
+            <a:off x="6208776" y="5115558"/>
             <a:ext cx="5623560" cy="256032"/>
           </a:xfrm>
           <a:prstGeom prst="rect">
@@ -17201,7 +16889,7 @@
           <a:p>
             <a:pPr algn="l"/>
             <a:r>
-              <a:rPr sz="1100" b="1" i="0">
+              <a:rPr sz="1100" b="1" i="0" dirty="0">
                 <a:solidFill>
                   <a:srgbClr val="FFFFFF"/>
                 </a:solidFill>
@@ -17219,8 +16907,8 @@
         </p:nvSpPr>
         <p:spPr>
           <a:xfrm>
-            <a:off x="6080760" y="5084064"/>
-            <a:ext cx="5852160" cy="1417320"/>
+            <a:off x="6080760" y="5417818"/>
+            <a:ext cx="5852160" cy="1083565"/>
           </a:xfrm>
           <a:prstGeom prst="rect">
             <a:avLst/>
@@ -17263,7 +16951,7 @@
         </p:nvSpPr>
         <p:spPr>
           <a:xfrm>
-            <a:off x="6236208" y="5148072"/>
+            <a:off x="6204204" y="5513244"/>
             <a:ext cx="5541264" cy="370332"/>
           </a:xfrm>
           <a:prstGeom prst="rect">
@@ -17279,7 +16967,7 @@
           <a:p>
             <a:pPr algn="l"/>
             <a:r>
-              <a:rPr sz="950" b="0" i="0">
+              <a:rPr sz="950" b="0" i="0" dirty="0">
                 <a:solidFill>
                   <a:srgbClr val="2C2C2C"/>
                 </a:solidFill>
@@ -17297,7 +16985,7 @@
         </p:nvSpPr>
         <p:spPr>
           <a:xfrm>
-            <a:off x="6236208" y="5472683"/>
+            <a:off x="6176772" y="5757846"/>
             <a:ext cx="5541264" cy="370332"/>
           </a:xfrm>
           <a:prstGeom prst="rect">
@@ -17313,12 +17001,28 @@
           <a:p>
             <a:pPr algn="l"/>
             <a:r>
-              <a:rPr sz="950" b="0" i="0">
+              <a:rPr sz="950" b="0" i="0" dirty="0">
                 <a:solidFill>
                   <a:srgbClr val="2C2C2C"/>
                 </a:solidFill>
               </a:rPr>
-              <a:t>▸  GridSearchCV tuned: depth=22, trees=70, leaf=5</a:t>
+              <a:t>▸  </a:t>
+            </a:r>
+            <a:r>
+              <a:rPr sz="950" b="0" i="0" dirty="0" err="1">
+                <a:solidFill>
+                  <a:srgbClr val="2C2C2C"/>
+                </a:solidFill>
+              </a:rPr>
+              <a:t>GridSearchCV</a:t>
+            </a:r>
+            <a:r>
+              <a:rPr sz="950" b="0" i="0" dirty="0">
+                <a:solidFill>
+                  <a:srgbClr val="2C2C2C"/>
+                </a:solidFill>
+              </a:rPr>
+              <a:t> tuned: depth=22, trees=70, leaf=5</a:t>
             </a:r>
           </a:p>
         </p:txBody>
@@ -17331,7 +17035,7 @@
         </p:nvSpPr>
         <p:spPr>
           <a:xfrm>
-            <a:off x="6236208" y="5797296"/>
+            <a:off x="6197600" y="5982637"/>
             <a:ext cx="5541264" cy="370332"/>
           </a:xfrm>
           <a:prstGeom prst="rect">
@@ -17347,13 +17051,26 @@
           <a:p>
             <a:pPr algn="l"/>
             <a:r>
-              <a:rPr sz="950" b="0" i="0">
+              <a:rPr sz="950" b="0" i="0" dirty="0">
                 <a:solidFill>
                   <a:srgbClr val="2C2C2C"/>
                 </a:solidFill>
               </a:rPr>
-              <a:t>▸  5-fold CV accuracy ~92% — robust generalisation</a:t>
-            </a:r>
+              <a:t>▸  5-fold CV accuracy ~92% — robust </a:t>
+            </a:r>
+            <a:r>
+              <a:rPr sz="950" b="0" i="0" dirty="0" err="1">
+                <a:solidFill>
+                  <a:srgbClr val="2C2C2C"/>
+                </a:solidFill>
+              </a:rPr>
+              <a:t>generalisation</a:t>
+            </a:r>
+            <a:endParaRPr sz="950" b="0" i="0" dirty="0">
+              <a:solidFill>
+                <a:srgbClr val="2C2C2C"/>
+              </a:solidFill>
+            </a:endParaRPr>
           </a:p>
         </p:txBody>
       </p:sp>
@@ -17365,7 +17082,7 @@
         </p:nvSpPr>
         <p:spPr>
           <a:xfrm>
-            <a:off x="6236208" y="6121908"/>
+            <a:off x="6190488" y="6231636"/>
             <a:ext cx="5541264" cy="370332"/>
           </a:xfrm>
           <a:prstGeom prst="rect">
@@ -17381,12 +17098,379 @@
           <a:p>
             <a:pPr algn="l"/>
             <a:r>
-              <a:rPr sz="950" b="0" i="0">
+              <a:rPr sz="950" b="0" i="0" dirty="0">
                 <a:solidFill>
                   <a:srgbClr val="2C2C2C"/>
                 </a:solidFill>
               </a:rPr>
-              <a:t>▸  Balanced subsample class_weight handles imbalance</a:t>
+              <a:t>▸  Balanced subsample </a:t>
+            </a:r>
+            <a:r>
+              <a:rPr sz="950" b="0" i="0" dirty="0" err="1">
+                <a:solidFill>
+                  <a:srgbClr val="2C2C2C"/>
+                </a:solidFill>
+              </a:rPr>
+              <a:t>class_weight</a:t>
+            </a:r>
+            <a:r>
+              <a:rPr sz="950" b="0" i="0" dirty="0">
+                <a:solidFill>
+                  <a:srgbClr val="2C2C2C"/>
+                </a:solidFill>
+              </a:rPr>
+              <a:t> handles imbalance</a:t>
+            </a:r>
+          </a:p>
+        </p:txBody>
+      </p:sp>
+      <p:sp>
+        <p:nvSpPr>
+          <p:cNvPr id="71" name="Rectangle 70">
+            <a:extLst>
+              <a:ext uri="{FF2B5EF4-FFF2-40B4-BE49-F238E27FC236}">
+                <a16:creationId xmlns:a16="http://schemas.microsoft.com/office/drawing/2014/main" id="{C96AAA03-5ACC-12DB-7FB0-8A5905590560}"/>
+              </a:ext>
+            </a:extLst>
+          </p:cNvPr>
+          <p:cNvSpPr/>
+          <p:nvPr/>
+        </p:nvSpPr>
+        <p:spPr>
+          <a:xfrm>
+            <a:off x="256032" y="3253231"/>
+            <a:ext cx="11676888" cy="429768"/>
+          </a:xfrm>
+          <a:prstGeom prst="rect">
+            <a:avLst/>
+          </a:prstGeom>
+          <a:solidFill>
+            <a:srgbClr val="EEE8DD"/>
+          </a:solidFill>
+          <a:ln>
+            <a:noFill/>
+          </a:ln>
+        </p:spPr>
+        <p:style>
+          <a:lnRef idx="1">
+            <a:schemeClr val="accent1"/>
+          </a:lnRef>
+          <a:fillRef idx="3">
+            <a:schemeClr val="accent1"/>
+          </a:fillRef>
+          <a:effectRef idx="2">
+            <a:schemeClr val="accent1"/>
+          </a:effectRef>
+          <a:fontRef idx="minor">
+            <a:schemeClr val="lt1"/>
+          </a:fontRef>
+        </p:style>
+        <p:txBody>
+          <a:bodyPr rtlCol="0" anchor="ctr"/>
+          <a:lstStyle/>
+          <a:p>
+            <a:pPr algn="ctr"/>
+            <a:endParaRPr/>
+          </a:p>
+        </p:txBody>
+      </p:sp>
+      <p:sp>
+        <p:nvSpPr>
+          <p:cNvPr id="72" name="TextBox 71">
+            <a:extLst>
+              <a:ext uri="{FF2B5EF4-FFF2-40B4-BE49-F238E27FC236}">
+                <a16:creationId xmlns:a16="http://schemas.microsoft.com/office/drawing/2014/main" id="{005E6641-1F42-BAB7-EDD8-2023BBC906D2}"/>
+              </a:ext>
+            </a:extLst>
+          </p:cNvPr>
+          <p:cNvSpPr txBox="1"/>
+          <p:nvPr/>
+        </p:nvSpPr>
+        <p:spPr>
+          <a:xfrm>
+            <a:off x="365760" y="3335527"/>
+            <a:ext cx="2286000" cy="253916"/>
+          </a:xfrm>
+          <a:prstGeom prst="rect">
+            <a:avLst/>
+          </a:prstGeom>
+          <a:noFill/>
+        </p:spPr>
+        <p:txBody>
+          <a:bodyPr wrap="square">
+            <a:spAutoFit/>
+          </a:bodyPr>
+          <a:lstStyle/>
+          <a:p>
+            <a:pPr algn="l"/>
+            <a:r>
+              <a:rPr lang="en-US" sz="1050" b="1" i="0" dirty="0">
+                <a:solidFill>
+                  <a:srgbClr val="1B3A4B"/>
+                </a:solidFill>
+              </a:rPr>
+              <a:t>Recall</a:t>
+            </a:r>
+            <a:endParaRPr sz="1050" b="1" i="0" dirty="0">
+              <a:solidFill>
+                <a:srgbClr val="1B3A4B"/>
+              </a:solidFill>
+            </a:endParaRPr>
+          </a:p>
+        </p:txBody>
+      </p:sp>
+      <p:sp>
+        <p:nvSpPr>
+          <p:cNvPr id="73" name="TextBox 72">
+            <a:extLst>
+              <a:ext uri="{FF2B5EF4-FFF2-40B4-BE49-F238E27FC236}">
+                <a16:creationId xmlns:a16="http://schemas.microsoft.com/office/drawing/2014/main" id="{4795BA90-F0D8-F406-392C-41D0941A7422}"/>
+              </a:ext>
+            </a:extLst>
+          </p:cNvPr>
+          <p:cNvSpPr txBox="1"/>
+          <p:nvPr/>
+        </p:nvSpPr>
+        <p:spPr>
+          <a:xfrm>
+            <a:off x="2816351" y="3335527"/>
+            <a:ext cx="1920240" cy="253916"/>
+          </a:xfrm>
+          <a:prstGeom prst="rect">
+            <a:avLst/>
+          </a:prstGeom>
+          <a:noFill/>
+        </p:spPr>
+        <p:txBody>
+          <a:bodyPr wrap="square">
+            <a:spAutoFit/>
+          </a:bodyPr>
+          <a:lstStyle/>
+          <a:p>
+            <a:pPr algn="ctr"/>
+            <a:r>
+              <a:rPr sz="1050" b="0" i="0" dirty="0">
+                <a:solidFill>
+                  <a:srgbClr val="2C2C2C"/>
+                </a:solidFill>
+              </a:rPr>
+              <a:t>8</a:t>
+            </a:r>
+            <a:r>
+              <a:rPr lang="en-US" sz="1050" b="0" i="0" dirty="0">
+                <a:solidFill>
+                  <a:srgbClr val="2C2C2C"/>
+                </a:solidFill>
+              </a:rPr>
+              <a:t>8</a:t>
+            </a:r>
+            <a:r>
+              <a:rPr sz="1050" b="0" i="0" dirty="0">
+                <a:solidFill>
+                  <a:srgbClr val="2C2C2C"/>
+                </a:solidFill>
+              </a:rPr>
+              <a:t>.</a:t>
+            </a:r>
+            <a:r>
+              <a:rPr lang="en-US" sz="1050" b="0" i="0" dirty="0">
+                <a:solidFill>
+                  <a:srgbClr val="2C2C2C"/>
+                </a:solidFill>
+              </a:rPr>
+              <a:t>57</a:t>
+            </a:r>
+            <a:r>
+              <a:rPr sz="1050" b="0" i="0" dirty="0">
+                <a:solidFill>
+                  <a:srgbClr val="2C2C2C"/>
+                </a:solidFill>
+              </a:rPr>
+              <a:t>%</a:t>
+            </a:r>
+          </a:p>
+        </p:txBody>
+      </p:sp>
+      <p:sp>
+        <p:nvSpPr>
+          <p:cNvPr id="74" name="TextBox 73">
+            <a:extLst>
+              <a:ext uri="{FF2B5EF4-FFF2-40B4-BE49-F238E27FC236}">
+                <a16:creationId xmlns:a16="http://schemas.microsoft.com/office/drawing/2014/main" id="{F6887E76-EEC0-8D5E-2048-34200853C153}"/>
+              </a:ext>
+            </a:extLst>
+          </p:cNvPr>
+          <p:cNvSpPr txBox="1"/>
+          <p:nvPr/>
+        </p:nvSpPr>
+        <p:spPr>
+          <a:xfrm>
+            <a:off x="4873752" y="3335527"/>
+            <a:ext cx="2057400" cy="253916"/>
+          </a:xfrm>
+          <a:prstGeom prst="rect">
+            <a:avLst/>
+          </a:prstGeom>
+          <a:noFill/>
+        </p:spPr>
+        <p:txBody>
+          <a:bodyPr wrap="square">
+            <a:spAutoFit/>
+          </a:bodyPr>
+          <a:lstStyle/>
+          <a:p>
+            <a:pPr algn="ctr"/>
+            <a:r>
+              <a:rPr lang="en-US" sz="1050" b="0" i="0" dirty="0">
+                <a:solidFill>
+                  <a:srgbClr val="2C2C2C"/>
+                </a:solidFill>
+              </a:rPr>
+              <a:t>81.08</a:t>
+            </a:r>
+            <a:r>
+              <a:rPr sz="1050" b="0" i="0" dirty="0">
+                <a:solidFill>
+                  <a:srgbClr val="2C2C2C"/>
+                </a:solidFill>
+              </a:rPr>
+              <a:t>%</a:t>
+            </a:r>
+          </a:p>
+        </p:txBody>
+      </p:sp>
+      <p:sp>
+        <p:nvSpPr>
+          <p:cNvPr id="75" name="TextBox 74">
+            <a:extLst>
+              <a:ext uri="{FF2B5EF4-FFF2-40B4-BE49-F238E27FC236}">
+                <a16:creationId xmlns:a16="http://schemas.microsoft.com/office/drawing/2014/main" id="{44498CE9-8362-57C0-1B0E-FCCD61D0671B}"/>
+              </a:ext>
+            </a:extLst>
+          </p:cNvPr>
+          <p:cNvSpPr txBox="1"/>
+          <p:nvPr/>
+        </p:nvSpPr>
+        <p:spPr>
+          <a:xfrm>
+            <a:off x="7068312" y="3335527"/>
+            <a:ext cx="1920240" cy="253916"/>
+          </a:xfrm>
+          <a:prstGeom prst="rect">
+            <a:avLst/>
+          </a:prstGeom>
+          <a:noFill/>
+        </p:spPr>
+        <p:txBody>
+          <a:bodyPr wrap="square">
+            <a:spAutoFit/>
+          </a:bodyPr>
+          <a:lstStyle/>
+          <a:p>
+            <a:pPr algn="ctr"/>
+            <a:r>
+              <a:rPr sz="1050" b="0" i="0" dirty="0">
+                <a:solidFill>
+                  <a:srgbClr val="2C2C2C"/>
+                </a:solidFill>
+              </a:rPr>
+              <a:t>9</a:t>
+            </a:r>
+            <a:r>
+              <a:rPr lang="en-US" sz="1050" b="0" i="0" dirty="0">
+                <a:solidFill>
+                  <a:srgbClr val="2C2C2C"/>
+                </a:solidFill>
+              </a:rPr>
+              <a:t>6</a:t>
+            </a:r>
+            <a:r>
+              <a:rPr sz="1050" b="0" i="0" dirty="0">
+                <a:solidFill>
+                  <a:srgbClr val="2C2C2C"/>
+                </a:solidFill>
+              </a:rPr>
+              <a:t>.7</a:t>
+            </a:r>
+            <a:r>
+              <a:rPr lang="en-US" sz="1050" b="0" i="0" dirty="0">
+                <a:solidFill>
+                  <a:srgbClr val="2C2C2C"/>
+                </a:solidFill>
+              </a:rPr>
+              <a:t>6</a:t>
+            </a:r>
+            <a:r>
+              <a:rPr sz="1050" b="0" i="0" dirty="0">
+                <a:solidFill>
+                  <a:srgbClr val="2C2C2C"/>
+                </a:solidFill>
+              </a:rPr>
+              <a:t>%</a:t>
+            </a:r>
+          </a:p>
+        </p:txBody>
+      </p:sp>
+      <p:sp>
+        <p:nvSpPr>
+          <p:cNvPr id="76" name="TextBox 75">
+            <a:extLst>
+              <a:ext uri="{FF2B5EF4-FFF2-40B4-BE49-F238E27FC236}">
+                <a16:creationId xmlns:a16="http://schemas.microsoft.com/office/drawing/2014/main" id="{36453C5F-48EC-57B3-31AE-1DD3AD158E76}"/>
+              </a:ext>
+            </a:extLst>
+          </p:cNvPr>
+          <p:cNvSpPr txBox="1"/>
+          <p:nvPr/>
+        </p:nvSpPr>
+        <p:spPr>
+          <a:xfrm>
+            <a:off x="9125712" y="3335527"/>
+            <a:ext cx="1920240" cy="253916"/>
+          </a:xfrm>
+          <a:prstGeom prst="rect">
+            <a:avLst/>
+          </a:prstGeom>
+          <a:noFill/>
+        </p:spPr>
+        <p:txBody>
+          <a:bodyPr wrap="square">
+            <a:spAutoFit/>
+          </a:bodyPr>
+          <a:lstStyle/>
+          <a:p>
+            <a:pPr algn="ctr"/>
+            <a:r>
+              <a:rPr lang="en-US" sz="1050" b="0" i="0" dirty="0">
+                <a:solidFill>
+                  <a:srgbClr val="2C2C2C"/>
+                </a:solidFill>
+              </a:rPr>
+              <a:t>81</a:t>
+            </a:r>
+            <a:r>
+              <a:rPr sz="1050" b="0" i="0" dirty="0">
+                <a:solidFill>
+                  <a:srgbClr val="2C2C2C"/>
+                </a:solidFill>
+              </a:rPr>
+              <a:t>.</a:t>
+            </a:r>
+            <a:r>
+              <a:rPr lang="en-US" sz="1050" dirty="0">
+                <a:solidFill>
+                  <a:srgbClr val="2C2C2C"/>
+                </a:solidFill>
+              </a:rPr>
+              <a:t>08</a:t>
+            </a:r>
+            <a:r>
+              <a:rPr sz="1050" b="0" i="0" dirty="0">
+                <a:solidFill>
+                  <a:srgbClr val="2C2C2C"/>
+                </a:solidFill>
+              </a:rPr>
+              <a:t>%</a:t>
             </a:r>
           </a:p>
         </p:txBody>
@@ -17728,9 +17812,862 @@
           </a:p>
         </p:txBody>
       </p:sp>
+      <p:sp>
+        <p:nvSpPr>
+          <p:cNvPr id="11" name="Rectangle 10"/>
+          <p:cNvSpPr/>
+          <p:nvPr/>
+        </p:nvSpPr>
+        <p:spPr>
+          <a:xfrm>
+            <a:off x="7543800" y="1115567"/>
+            <a:ext cx="4389120" cy="2084831"/>
+          </a:xfrm>
+          <a:prstGeom prst="rect">
+            <a:avLst/>
+          </a:prstGeom>
+          <a:solidFill>
+            <a:srgbClr val="1B3A4B"/>
+          </a:solidFill>
+          <a:ln>
+            <a:noFill/>
+          </a:ln>
+        </p:spPr>
+        <p:style>
+          <a:lnRef idx="1">
+            <a:schemeClr val="accent1"/>
+          </a:lnRef>
+          <a:fillRef idx="3">
+            <a:schemeClr val="accent1"/>
+          </a:fillRef>
+          <a:effectRef idx="2">
+            <a:schemeClr val="accent1"/>
+          </a:effectRef>
+          <a:fontRef idx="minor">
+            <a:schemeClr val="lt1"/>
+          </a:fontRef>
+        </p:style>
+        <p:txBody>
+          <a:bodyPr rtlCol="0" anchor="ctr"/>
+          <a:lstStyle/>
+          <a:p>
+            <a:pPr algn="ctr"/>
+            <a:endParaRPr/>
+          </a:p>
+        </p:txBody>
+      </p:sp>
+      <p:sp>
+        <p:nvSpPr>
+          <p:cNvPr id="12" name="TextBox 11"/>
+          <p:cNvSpPr txBox="1"/>
+          <p:nvPr/>
+        </p:nvSpPr>
+        <p:spPr>
+          <a:xfrm>
+            <a:off x="7726679" y="1188720"/>
+            <a:ext cx="4023360" cy="320040"/>
+          </a:xfrm>
+          <a:prstGeom prst="rect">
+            <a:avLst/>
+          </a:prstGeom>
+          <a:noFill/>
+        </p:spPr>
+        <p:txBody>
+          <a:bodyPr wrap="square">
+            <a:spAutoFit/>
+          </a:bodyPr>
+          <a:lstStyle/>
+          <a:p>
+            <a:pPr algn="l"/>
+            <a:r>
+              <a:rPr sz="1100" b="1" i="0">
+                <a:solidFill>
+                  <a:srgbClr val="C9A456"/>
+                </a:solidFill>
+              </a:rPr>
+              <a:t>AUC-ROC SUMMARY</a:t>
+            </a:r>
+          </a:p>
+        </p:txBody>
+      </p:sp>
+      <p:sp>
+        <p:nvSpPr>
+          <p:cNvPr id="13" name="TextBox 12"/>
+          <p:cNvSpPr txBox="1"/>
+          <p:nvPr/>
+        </p:nvSpPr>
+        <p:spPr>
+          <a:xfrm>
+            <a:off x="7726679" y="1536192"/>
+            <a:ext cx="4023360" cy="256032"/>
+          </a:xfrm>
+          <a:prstGeom prst="rect">
+            <a:avLst/>
+          </a:prstGeom>
+          <a:noFill/>
+        </p:spPr>
+        <p:txBody>
+          <a:bodyPr wrap="square">
+            <a:spAutoFit/>
+          </a:bodyPr>
+          <a:lstStyle/>
+          <a:p>
+            <a:pPr algn="l"/>
+            <a:r>
+              <a:rPr sz="900" b="0" i="1">
+                <a:solidFill>
+                  <a:srgbClr val="A0988C"/>
+                </a:solidFill>
+              </a:rPr>
+              <a:t>Validation Set (299 records)</a:t>
+            </a:r>
+          </a:p>
+        </p:txBody>
+      </p:sp>
+      <p:sp>
+        <p:nvSpPr>
+          <p:cNvPr id="14" name="Rectangle 13"/>
+          <p:cNvSpPr/>
+          <p:nvPr/>
+        </p:nvSpPr>
+        <p:spPr>
+          <a:xfrm>
+            <a:off x="7543800" y="1783080"/>
+            <a:ext cx="4389120" cy="36576"/>
+          </a:xfrm>
+          <a:prstGeom prst="rect">
+            <a:avLst/>
+          </a:prstGeom>
+          <a:solidFill>
+            <a:srgbClr val="C9A456"/>
+          </a:solidFill>
+          <a:ln>
+            <a:noFill/>
+          </a:ln>
+        </p:spPr>
+        <p:style>
+          <a:lnRef idx="1">
+            <a:schemeClr val="accent1"/>
+          </a:lnRef>
+          <a:fillRef idx="3">
+            <a:schemeClr val="accent1"/>
+          </a:fillRef>
+          <a:effectRef idx="2">
+            <a:schemeClr val="accent1"/>
+          </a:effectRef>
+          <a:fontRef idx="minor">
+            <a:schemeClr val="lt1"/>
+          </a:fontRef>
+        </p:style>
+        <p:txBody>
+          <a:bodyPr rtlCol="0" anchor="ctr"/>
+          <a:lstStyle/>
+          <a:p>
+            <a:pPr algn="ctr"/>
+            <a:endParaRPr/>
+          </a:p>
+        </p:txBody>
+      </p:sp>
+      <p:sp>
+        <p:nvSpPr>
+          <p:cNvPr id="15" name="Rectangle 14"/>
+          <p:cNvSpPr/>
+          <p:nvPr/>
+        </p:nvSpPr>
+        <p:spPr>
+          <a:xfrm>
+            <a:off x="7543800" y="1901952"/>
+            <a:ext cx="4389120" cy="457200"/>
+          </a:xfrm>
+          <a:prstGeom prst="rect">
+            <a:avLst/>
+          </a:prstGeom>
+          <a:solidFill>
+            <a:srgbClr val="0E2432"/>
+          </a:solidFill>
+          <a:ln>
+            <a:noFill/>
+          </a:ln>
+        </p:spPr>
+        <p:style>
+          <a:lnRef idx="1">
+            <a:schemeClr val="accent1"/>
+          </a:lnRef>
+          <a:fillRef idx="3">
+            <a:schemeClr val="accent1"/>
+          </a:fillRef>
+          <a:effectRef idx="2">
+            <a:schemeClr val="accent1"/>
+          </a:effectRef>
+          <a:fontRef idx="minor">
+            <a:schemeClr val="lt1"/>
+          </a:fontRef>
+        </p:style>
+        <p:txBody>
+          <a:bodyPr rtlCol="0" anchor="ctr"/>
+          <a:lstStyle/>
+          <a:p>
+            <a:pPr algn="ctr"/>
+            <a:endParaRPr/>
+          </a:p>
+        </p:txBody>
+      </p:sp>
+      <p:sp>
+        <p:nvSpPr>
+          <p:cNvPr id="16" name="TextBox 15"/>
+          <p:cNvSpPr txBox="1"/>
+          <p:nvPr/>
+        </p:nvSpPr>
+        <p:spPr>
+          <a:xfrm>
+            <a:off x="7662672" y="1993392"/>
+            <a:ext cx="2560320" cy="292608"/>
+          </a:xfrm>
+          <a:prstGeom prst="rect">
+            <a:avLst/>
+          </a:prstGeom>
+          <a:noFill/>
+        </p:spPr>
+        <p:txBody>
+          <a:bodyPr wrap="square">
+            <a:spAutoFit/>
+          </a:bodyPr>
+          <a:lstStyle/>
+          <a:p>
+            <a:pPr algn="l"/>
+            <a:r>
+              <a:rPr sz="950" b="0" i="0">
+                <a:solidFill>
+                  <a:srgbClr val="FFFFFF"/>
+                </a:solidFill>
+              </a:rPr>
+              <a:t>Logistic Regression</a:t>
+            </a:r>
+          </a:p>
+        </p:txBody>
+      </p:sp>
+      <p:sp>
+        <p:nvSpPr>
+          <p:cNvPr id="17" name="TextBox 16"/>
+          <p:cNvSpPr txBox="1"/>
+          <p:nvPr/>
+        </p:nvSpPr>
+        <p:spPr>
+          <a:xfrm>
+            <a:off x="10378440" y="1956816"/>
+            <a:ext cx="1371600" cy="400110"/>
+          </a:xfrm>
+          <a:prstGeom prst="rect">
+            <a:avLst/>
+          </a:prstGeom>
+          <a:noFill/>
+        </p:spPr>
+        <p:txBody>
+          <a:bodyPr wrap="square">
+            <a:spAutoFit/>
+          </a:bodyPr>
+          <a:lstStyle/>
+          <a:p>
+            <a:pPr algn="r"/>
+            <a:r>
+              <a:rPr sz="2000" b="1" i="0" dirty="0">
+                <a:solidFill>
+                  <a:srgbClr val="4472A8"/>
+                </a:solidFill>
+              </a:rPr>
+              <a:t>0.8</a:t>
+            </a:r>
+            <a:r>
+              <a:rPr lang="en-US" sz="2000" b="1" i="0" dirty="0">
+                <a:solidFill>
+                  <a:srgbClr val="4472A8"/>
+                </a:solidFill>
+              </a:rPr>
+              <a:t>424</a:t>
+            </a:r>
+            <a:endParaRPr sz="2000" b="1" i="0" dirty="0">
+              <a:solidFill>
+                <a:srgbClr val="4472A8"/>
+              </a:solidFill>
+            </a:endParaRPr>
+          </a:p>
+        </p:txBody>
+      </p:sp>
+      <p:sp>
+        <p:nvSpPr>
+          <p:cNvPr id="18" name="Rectangle 17"/>
+          <p:cNvSpPr/>
+          <p:nvPr/>
+        </p:nvSpPr>
+        <p:spPr>
+          <a:xfrm>
+            <a:off x="7543800" y="2404872"/>
+            <a:ext cx="4389120" cy="457200"/>
+          </a:xfrm>
+          <a:prstGeom prst="rect">
+            <a:avLst/>
+          </a:prstGeom>
+          <a:solidFill>
+            <a:srgbClr val="0E2432"/>
+          </a:solidFill>
+          <a:ln>
+            <a:noFill/>
+          </a:ln>
+        </p:spPr>
+        <p:style>
+          <a:lnRef idx="1">
+            <a:schemeClr val="accent1"/>
+          </a:lnRef>
+          <a:fillRef idx="3">
+            <a:schemeClr val="accent1"/>
+          </a:fillRef>
+          <a:effectRef idx="2">
+            <a:schemeClr val="accent1"/>
+          </a:effectRef>
+          <a:fontRef idx="minor">
+            <a:schemeClr val="lt1"/>
+          </a:fontRef>
+        </p:style>
+        <p:txBody>
+          <a:bodyPr rtlCol="0" anchor="ctr"/>
+          <a:lstStyle/>
+          <a:p>
+            <a:pPr algn="ctr"/>
+            <a:endParaRPr/>
+          </a:p>
+        </p:txBody>
+      </p:sp>
+      <p:sp>
+        <p:nvSpPr>
+          <p:cNvPr id="19" name="TextBox 18"/>
+          <p:cNvSpPr txBox="1"/>
+          <p:nvPr/>
+        </p:nvSpPr>
+        <p:spPr>
+          <a:xfrm>
+            <a:off x="7662672" y="2496312"/>
+            <a:ext cx="2560320" cy="292608"/>
+          </a:xfrm>
+          <a:prstGeom prst="rect">
+            <a:avLst/>
+          </a:prstGeom>
+          <a:noFill/>
+        </p:spPr>
+        <p:txBody>
+          <a:bodyPr wrap="square">
+            <a:spAutoFit/>
+          </a:bodyPr>
+          <a:lstStyle/>
+          <a:p>
+            <a:pPr algn="l"/>
+            <a:r>
+              <a:rPr sz="950" b="0" i="0">
+                <a:solidFill>
+                  <a:srgbClr val="FFFFFF"/>
+                </a:solidFill>
+              </a:rPr>
+              <a:t>Random Forest (Tuned)</a:t>
+            </a:r>
+          </a:p>
+        </p:txBody>
+      </p:sp>
+      <p:sp>
+        <p:nvSpPr>
+          <p:cNvPr id="20" name="TextBox 19"/>
+          <p:cNvSpPr txBox="1"/>
+          <p:nvPr/>
+        </p:nvSpPr>
+        <p:spPr>
+          <a:xfrm>
+            <a:off x="10378440" y="2459736"/>
+            <a:ext cx="1371600" cy="400110"/>
+          </a:xfrm>
+          <a:prstGeom prst="rect">
+            <a:avLst/>
+          </a:prstGeom>
+          <a:noFill/>
+        </p:spPr>
+        <p:txBody>
+          <a:bodyPr wrap="square">
+            <a:spAutoFit/>
+          </a:bodyPr>
+          <a:lstStyle/>
+          <a:p>
+            <a:pPr algn="r"/>
+            <a:r>
+              <a:rPr sz="2000" b="1" i="0" dirty="0">
+                <a:solidFill>
+                  <a:srgbClr val="B5573A"/>
+                </a:solidFill>
+              </a:rPr>
+              <a:t>0.8</a:t>
+            </a:r>
+            <a:r>
+              <a:rPr lang="en-US" sz="2000" b="1" i="0" dirty="0">
+                <a:solidFill>
+                  <a:srgbClr val="B5573A"/>
+                </a:solidFill>
+              </a:rPr>
+              <a:t>351</a:t>
+            </a:r>
+            <a:endParaRPr sz="2000" b="1" i="0" dirty="0">
+              <a:solidFill>
+                <a:srgbClr val="B5573A"/>
+              </a:solidFill>
+            </a:endParaRPr>
+          </a:p>
+        </p:txBody>
+      </p:sp>
+      <p:sp>
+        <p:nvSpPr>
+          <p:cNvPr id="21" name="Rectangle 20"/>
+          <p:cNvSpPr/>
+          <p:nvPr/>
+        </p:nvSpPr>
+        <p:spPr>
+          <a:xfrm>
+            <a:off x="7543800" y="2907792"/>
+            <a:ext cx="4389120" cy="630936"/>
+          </a:xfrm>
+          <a:prstGeom prst="rect">
+            <a:avLst/>
+          </a:prstGeom>
+          <a:solidFill>
+            <a:srgbClr val="1B3A4B"/>
+          </a:solidFill>
+          <a:ln>
+            <a:noFill/>
+          </a:ln>
+        </p:spPr>
+        <p:style>
+          <a:lnRef idx="1">
+            <a:schemeClr val="accent1"/>
+          </a:lnRef>
+          <a:fillRef idx="3">
+            <a:schemeClr val="accent1"/>
+          </a:fillRef>
+          <a:effectRef idx="2">
+            <a:schemeClr val="accent1"/>
+          </a:effectRef>
+          <a:fontRef idx="minor">
+            <a:schemeClr val="lt1"/>
+          </a:fontRef>
+        </p:style>
+        <p:txBody>
+          <a:bodyPr rtlCol="0" anchor="ctr"/>
+          <a:lstStyle/>
+          <a:p>
+            <a:pPr algn="ctr"/>
+            <a:endParaRPr/>
+          </a:p>
+        </p:txBody>
+      </p:sp>
+      <p:sp>
+        <p:nvSpPr>
+          <p:cNvPr id="22" name="TextBox 21"/>
+          <p:cNvSpPr txBox="1"/>
+          <p:nvPr/>
+        </p:nvSpPr>
+        <p:spPr>
+          <a:xfrm>
+            <a:off x="7662672" y="2999232"/>
+            <a:ext cx="2560320" cy="292608"/>
+          </a:xfrm>
+          <a:prstGeom prst="rect">
+            <a:avLst/>
+          </a:prstGeom>
+          <a:noFill/>
+        </p:spPr>
+        <p:txBody>
+          <a:bodyPr wrap="square">
+            <a:spAutoFit/>
+          </a:bodyPr>
+          <a:lstStyle/>
+          <a:p>
+            <a:pPr algn="l"/>
+            <a:r>
+              <a:rPr sz="950" b="0" i="0">
+                <a:solidFill>
+                  <a:srgbClr val="FFFFFF"/>
+                </a:solidFill>
+              </a:rPr>
+              <a:t>Random (baseline)</a:t>
+            </a:r>
+          </a:p>
+        </p:txBody>
+      </p:sp>
+      <p:sp>
+        <p:nvSpPr>
+          <p:cNvPr id="23" name="TextBox 22"/>
+          <p:cNvSpPr txBox="1"/>
+          <p:nvPr/>
+        </p:nvSpPr>
+        <p:spPr>
+          <a:xfrm>
+            <a:off x="10378440" y="2962656"/>
+            <a:ext cx="1371600" cy="365760"/>
+          </a:xfrm>
+          <a:prstGeom prst="rect">
+            <a:avLst/>
+          </a:prstGeom>
+          <a:noFill/>
+        </p:spPr>
+        <p:txBody>
+          <a:bodyPr wrap="square">
+            <a:spAutoFit/>
+          </a:bodyPr>
+          <a:lstStyle/>
+          <a:p>
+            <a:pPr algn="r"/>
+            <a:r>
+              <a:rPr sz="2000" b="1" i="0">
+                <a:solidFill>
+                  <a:srgbClr val="5C5C5C"/>
+                </a:solidFill>
+              </a:rPr>
+              <a:t>0.500</a:t>
+            </a:r>
+          </a:p>
+        </p:txBody>
+      </p:sp>
+      <p:sp>
+        <p:nvSpPr>
+          <p:cNvPr id="25" name="TextBox 24"/>
+          <p:cNvSpPr txBox="1"/>
+          <p:nvPr/>
+        </p:nvSpPr>
+        <p:spPr>
+          <a:xfrm>
+            <a:off x="7662672" y="3200400"/>
+            <a:ext cx="4160520" cy="238527"/>
+          </a:xfrm>
+          <a:prstGeom prst="rect">
+            <a:avLst/>
+          </a:prstGeom>
+          <a:noFill/>
+        </p:spPr>
+        <p:txBody>
+          <a:bodyPr wrap="square">
+            <a:spAutoFit/>
+          </a:bodyPr>
+          <a:lstStyle/>
+          <a:p>
+            <a:r>
+              <a:rPr lang="en-IN" sz="950" b="1" dirty="0">
+                <a:solidFill>
+                  <a:srgbClr val="C9A456"/>
+                </a:solidFill>
+              </a:rPr>
+              <a:t> </a:t>
+            </a:r>
+            <a:endParaRPr sz="950" b="1" i="0" dirty="0">
+              <a:solidFill>
+                <a:srgbClr val="C9A456"/>
+              </a:solidFill>
+            </a:endParaRPr>
+          </a:p>
+        </p:txBody>
+      </p:sp>
+      <p:sp>
+        <p:nvSpPr>
+          <p:cNvPr id="26" name="Rectangle 25"/>
+          <p:cNvSpPr/>
+          <p:nvPr/>
+        </p:nvSpPr>
+        <p:spPr>
+          <a:xfrm>
+            <a:off x="7543800" y="3703320"/>
+            <a:ext cx="4389120" cy="347472"/>
+          </a:xfrm>
+          <a:prstGeom prst="rect">
+            <a:avLst/>
+          </a:prstGeom>
+          <a:solidFill>
+            <a:srgbClr val="4472A8"/>
+          </a:solidFill>
+          <a:ln>
+            <a:noFill/>
+          </a:ln>
+        </p:spPr>
+        <p:style>
+          <a:lnRef idx="1">
+            <a:schemeClr val="accent1"/>
+          </a:lnRef>
+          <a:fillRef idx="3">
+            <a:schemeClr val="accent1"/>
+          </a:fillRef>
+          <a:effectRef idx="2">
+            <a:schemeClr val="accent1"/>
+          </a:effectRef>
+          <a:fontRef idx="minor">
+            <a:schemeClr val="lt1"/>
+          </a:fontRef>
+        </p:style>
+        <p:txBody>
+          <a:bodyPr rtlCol="0" anchor="ctr"/>
+          <a:lstStyle/>
+          <a:p>
+            <a:pPr algn="ctr"/>
+            <a:endParaRPr/>
+          </a:p>
+        </p:txBody>
+      </p:sp>
+      <p:sp>
+        <p:nvSpPr>
+          <p:cNvPr id="27" name="TextBox 26"/>
+          <p:cNvSpPr txBox="1"/>
+          <p:nvPr/>
+        </p:nvSpPr>
+        <p:spPr>
+          <a:xfrm>
+            <a:off x="7662672" y="3739896"/>
+            <a:ext cx="4160520" cy="274320"/>
+          </a:xfrm>
+          <a:prstGeom prst="rect">
+            <a:avLst/>
+          </a:prstGeom>
+          <a:noFill/>
+        </p:spPr>
+        <p:txBody>
+          <a:bodyPr wrap="square">
+            <a:spAutoFit/>
+          </a:bodyPr>
+          <a:lstStyle/>
+          <a:p>
+            <a:pPr algn="l"/>
+            <a:r>
+              <a:rPr sz="1000" b="1" i="0">
+                <a:solidFill>
+                  <a:srgbClr val="FFFFFF"/>
+                </a:solidFill>
+              </a:rPr>
+              <a:t>What these AUC scores mean</a:t>
+            </a:r>
+          </a:p>
+        </p:txBody>
+      </p:sp>
+      <p:sp>
+        <p:nvSpPr>
+          <p:cNvPr id="28" name="Rectangle 27"/>
+          <p:cNvSpPr/>
+          <p:nvPr/>
+        </p:nvSpPr>
+        <p:spPr>
+          <a:xfrm>
+            <a:off x="7543800" y="4050791"/>
+            <a:ext cx="4389120" cy="1920240"/>
+          </a:xfrm>
+          <a:prstGeom prst="rect">
+            <a:avLst/>
+          </a:prstGeom>
+          <a:solidFill>
+            <a:srgbClr val="EEE8DD"/>
+          </a:solidFill>
+          <a:ln>
+            <a:noFill/>
+          </a:ln>
+        </p:spPr>
+        <p:style>
+          <a:lnRef idx="1">
+            <a:schemeClr val="accent1"/>
+          </a:lnRef>
+          <a:fillRef idx="3">
+            <a:schemeClr val="accent1"/>
+          </a:fillRef>
+          <a:effectRef idx="2">
+            <a:schemeClr val="accent1"/>
+          </a:effectRef>
+          <a:fontRef idx="minor">
+            <a:schemeClr val="lt1"/>
+          </a:fontRef>
+        </p:style>
+        <p:txBody>
+          <a:bodyPr rtlCol="0" anchor="ctr"/>
+          <a:lstStyle/>
+          <a:p>
+            <a:pPr algn="ctr"/>
+            <a:endParaRPr/>
+          </a:p>
+        </p:txBody>
+      </p:sp>
+      <p:sp>
+        <p:nvSpPr>
+          <p:cNvPr id="29" name="TextBox 28"/>
+          <p:cNvSpPr txBox="1"/>
+          <p:nvPr/>
+        </p:nvSpPr>
+        <p:spPr>
+          <a:xfrm>
+            <a:off x="7662672" y="4114800"/>
+            <a:ext cx="4160520" cy="369332"/>
+          </a:xfrm>
+          <a:prstGeom prst="rect">
+            <a:avLst/>
+          </a:prstGeom>
+          <a:noFill/>
+        </p:spPr>
+        <p:txBody>
+          <a:bodyPr wrap="square">
+            <a:spAutoFit/>
+          </a:bodyPr>
+          <a:lstStyle/>
+          <a:p>
+            <a:pPr algn="l"/>
+            <a:r>
+              <a:rPr sz="900" b="0" i="0" dirty="0">
+                <a:solidFill>
+                  <a:srgbClr val="2C2C2C"/>
+                </a:solidFill>
+              </a:rPr>
+              <a:t>▸  AUC 0.8</a:t>
+            </a:r>
+            <a:r>
+              <a:rPr lang="en-US" sz="900" b="0" i="0" dirty="0">
+                <a:solidFill>
+                  <a:srgbClr val="2C2C2C"/>
+                </a:solidFill>
+              </a:rPr>
+              <a:t>351</a:t>
+            </a:r>
+            <a:r>
+              <a:rPr sz="900" b="0" i="0" dirty="0">
+                <a:solidFill>
+                  <a:srgbClr val="2C2C2C"/>
+                </a:solidFill>
+              </a:rPr>
+              <a:t>: RF correctly ranks a random fraud
+  claim above a legit one 8</a:t>
+            </a:r>
+            <a:r>
+              <a:rPr lang="en-US" sz="900" b="0" i="0" dirty="0">
+                <a:solidFill>
+                  <a:srgbClr val="2C2C2C"/>
+                </a:solidFill>
+              </a:rPr>
+              <a:t>3</a:t>
+            </a:r>
+            <a:r>
+              <a:rPr sz="900" b="0" i="0" dirty="0">
+                <a:solidFill>
+                  <a:srgbClr val="2C2C2C"/>
+                </a:solidFill>
+              </a:rPr>
+              <a:t>.</a:t>
+            </a:r>
+            <a:r>
+              <a:rPr lang="en-US" sz="900" b="0" i="0" dirty="0">
+                <a:solidFill>
+                  <a:srgbClr val="2C2C2C"/>
+                </a:solidFill>
+              </a:rPr>
+              <a:t>5</a:t>
+            </a:r>
+            <a:r>
+              <a:rPr sz="900" b="0" i="0" dirty="0">
+                <a:solidFill>
+                  <a:srgbClr val="2C2C2C"/>
+                </a:solidFill>
+              </a:rPr>
+              <a:t>% of the time</a:t>
+            </a:r>
+          </a:p>
+        </p:txBody>
+      </p:sp>
+      <p:sp>
+        <p:nvSpPr>
+          <p:cNvPr id="30" name="TextBox 29"/>
+          <p:cNvSpPr txBox="1"/>
+          <p:nvPr/>
+        </p:nvSpPr>
+        <p:spPr>
+          <a:xfrm>
+            <a:off x="7662672" y="4572000"/>
+            <a:ext cx="4160520" cy="369332"/>
+          </a:xfrm>
+          <a:prstGeom prst="rect">
+            <a:avLst/>
+          </a:prstGeom>
+          <a:noFill/>
+        </p:spPr>
+        <p:txBody>
+          <a:bodyPr wrap="square">
+            <a:spAutoFit/>
+          </a:bodyPr>
+          <a:lstStyle/>
+          <a:p>
+            <a:pPr algn="l"/>
+            <a:r>
+              <a:rPr sz="900" b="0" i="0" dirty="0">
+                <a:solidFill>
+                  <a:srgbClr val="2C2C2C"/>
+                </a:solidFill>
+              </a:rPr>
+              <a:t>▸  AUC 0.8</a:t>
+            </a:r>
+            <a:r>
+              <a:rPr lang="en-US" sz="900" b="0" i="0" dirty="0">
+                <a:solidFill>
+                  <a:srgbClr val="2C2C2C"/>
+                </a:solidFill>
+              </a:rPr>
+              <a:t>424</a:t>
+            </a:r>
+            <a:r>
+              <a:rPr sz="900" b="0" i="0" dirty="0">
+                <a:solidFill>
+                  <a:srgbClr val="2C2C2C"/>
+                </a:solidFill>
+              </a:rPr>
+              <a:t>: LR is also strong — suitable when
+  interpretability is required</a:t>
+            </a:r>
+          </a:p>
+        </p:txBody>
+      </p:sp>
+      <p:sp>
+        <p:nvSpPr>
+          <p:cNvPr id="31" name="TextBox 30"/>
+          <p:cNvSpPr txBox="1"/>
+          <p:nvPr/>
+        </p:nvSpPr>
+        <p:spPr>
+          <a:xfrm>
+            <a:off x="7662672" y="5029200"/>
+            <a:ext cx="4160520" cy="438912"/>
+          </a:xfrm>
+          <a:prstGeom prst="rect">
+            <a:avLst/>
+          </a:prstGeom>
+          <a:noFill/>
+        </p:spPr>
+        <p:txBody>
+          <a:bodyPr wrap="square">
+            <a:spAutoFit/>
+          </a:bodyPr>
+          <a:lstStyle/>
+          <a:p>
+            <a:pPr algn="l"/>
+            <a:r>
+              <a:rPr sz="900" b="0" i="0">
+                <a:solidFill>
+                  <a:srgbClr val="2C2C2C"/>
+                </a:solidFill>
+              </a:rPr>
+              <a:t>▸  Both models far exceed random (0.50),
+  confirming genuine predictive power</a:t>
+            </a:r>
+          </a:p>
+        </p:txBody>
+      </p:sp>
       <p:pic>
         <p:nvPicPr>
-          <p:cNvPr id="10" name="Picture 9" descr="plot_roc_comparison.png"/>
+          <p:cNvPr id="24" name="Picture 23">
+            <a:extLst>
+              <a:ext uri="{FF2B5EF4-FFF2-40B4-BE49-F238E27FC236}">
+                <a16:creationId xmlns:a16="http://schemas.microsoft.com/office/drawing/2014/main" id="{7DEA1DF7-AA80-E4C9-A456-808ABA6F1890}"/>
+              </a:ext>
+            </a:extLst>
+          </p:cNvPr>
           <p:cNvPicPr>
             <a:picLocks noChangeAspect="1"/>
           </p:cNvPicPr>
@@ -17744,802 +18681,14 @@
         </p:blipFill>
         <p:spPr>
           <a:xfrm>
-            <a:off x="457200" y="1115568"/>
-            <a:ext cx="6858000" cy="5029200"/>
+            <a:off x="838299" y="1221332"/>
+            <a:ext cx="6449469" cy="4808528"/>
           </a:xfrm>
           <a:prstGeom prst="rect">
             <a:avLst/>
           </a:prstGeom>
         </p:spPr>
       </p:pic>
-      <p:sp>
-        <p:nvSpPr>
-          <p:cNvPr id="11" name="Rectangle 10"/>
-          <p:cNvSpPr/>
-          <p:nvPr/>
-        </p:nvSpPr>
-        <p:spPr>
-          <a:xfrm>
-            <a:off x="7543800" y="1115567"/>
-            <a:ext cx="4389120" cy="2084831"/>
-          </a:xfrm>
-          <a:prstGeom prst="rect">
-            <a:avLst/>
-          </a:prstGeom>
-          <a:solidFill>
-            <a:srgbClr val="1B3A4B"/>
-          </a:solidFill>
-          <a:ln>
-            <a:noFill/>
-          </a:ln>
-        </p:spPr>
-        <p:style>
-          <a:lnRef idx="1">
-            <a:schemeClr val="accent1"/>
-          </a:lnRef>
-          <a:fillRef idx="3">
-            <a:schemeClr val="accent1"/>
-          </a:fillRef>
-          <a:effectRef idx="2">
-            <a:schemeClr val="accent1"/>
-          </a:effectRef>
-          <a:fontRef idx="minor">
-            <a:schemeClr val="lt1"/>
-          </a:fontRef>
-        </p:style>
-        <p:txBody>
-          <a:bodyPr rtlCol="0" anchor="ctr"/>
-          <a:lstStyle/>
-          <a:p>
-            <a:pPr algn="ctr"/>
-            <a:endParaRPr/>
-          </a:p>
-        </p:txBody>
-      </p:sp>
-      <p:sp>
-        <p:nvSpPr>
-          <p:cNvPr id="12" name="TextBox 11"/>
-          <p:cNvSpPr txBox="1"/>
-          <p:nvPr/>
-        </p:nvSpPr>
-        <p:spPr>
-          <a:xfrm>
-            <a:off x="7726679" y="1188720"/>
-            <a:ext cx="4023360" cy="320040"/>
-          </a:xfrm>
-          <a:prstGeom prst="rect">
-            <a:avLst/>
-          </a:prstGeom>
-          <a:noFill/>
-        </p:spPr>
-        <p:txBody>
-          <a:bodyPr wrap="square">
-            <a:spAutoFit/>
-          </a:bodyPr>
-          <a:lstStyle/>
-          <a:p>
-            <a:pPr algn="l"/>
-            <a:r>
-              <a:rPr sz="1100" b="1" i="0">
-                <a:solidFill>
-                  <a:srgbClr val="C9A456"/>
-                </a:solidFill>
-              </a:rPr>
-              <a:t>AUC-ROC SUMMARY</a:t>
-            </a:r>
-          </a:p>
-        </p:txBody>
-      </p:sp>
-      <p:sp>
-        <p:nvSpPr>
-          <p:cNvPr id="13" name="TextBox 12"/>
-          <p:cNvSpPr txBox="1"/>
-          <p:nvPr/>
-        </p:nvSpPr>
-        <p:spPr>
-          <a:xfrm>
-            <a:off x="7726679" y="1536192"/>
-            <a:ext cx="4023360" cy="256032"/>
-          </a:xfrm>
-          <a:prstGeom prst="rect">
-            <a:avLst/>
-          </a:prstGeom>
-          <a:noFill/>
-        </p:spPr>
-        <p:txBody>
-          <a:bodyPr wrap="square">
-            <a:spAutoFit/>
-          </a:bodyPr>
-          <a:lstStyle/>
-          <a:p>
-            <a:pPr algn="l"/>
-            <a:r>
-              <a:rPr sz="900" b="0" i="1">
-                <a:solidFill>
-                  <a:srgbClr val="A0988C"/>
-                </a:solidFill>
-              </a:rPr>
-              <a:t>Validation Set (299 records)</a:t>
-            </a:r>
-          </a:p>
-        </p:txBody>
-      </p:sp>
-      <p:sp>
-        <p:nvSpPr>
-          <p:cNvPr id="14" name="Rectangle 13"/>
-          <p:cNvSpPr/>
-          <p:nvPr/>
-        </p:nvSpPr>
-        <p:spPr>
-          <a:xfrm>
-            <a:off x="7543800" y="1783080"/>
-            <a:ext cx="4389120" cy="36576"/>
-          </a:xfrm>
-          <a:prstGeom prst="rect">
-            <a:avLst/>
-          </a:prstGeom>
-          <a:solidFill>
-            <a:srgbClr val="C9A456"/>
-          </a:solidFill>
-          <a:ln>
-            <a:noFill/>
-          </a:ln>
-        </p:spPr>
-        <p:style>
-          <a:lnRef idx="1">
-            <a:schemeClr val="accent1"/>
-          </a:lnRef>
-          <a:fillRef idx="3">
-            <a:schemeClr val="accent1"/>
-          </a:fillRef>
-          <a:effectRef idx="2">
-            <a:schemeClr val="accent1"/>
-          </a:effectRef>
-          <a:fontRef idx="minor">
-            <a:schemeClr val="lt1"/>
-          </a:fontRef>
-        </p:style>
-        <p:txBody>
-          <a:bodyPr rtlCol="0" anchor="ctr"/>
-          <a:lstStyle/>
-          <a:p>
-            <a:pPr algn="ctr"/>
-            <a:endParaRPr/>
-          </a:p>
-        </p:txBody>
-      </p:sp>
-      <p:sp>
-        <p:nvSpPr>
-          <p:cNvPr id="15" name="Rectangle 14"/>
-          <p:cNvSpPr/>
-          <p:nvPr/>
-        </p:nvSpPr>
-        <p:spPr>
-          <a:xfrm>
-            <a:off x="7543800" y="1901952"/>
-            <a:ext cx="4389120" cy="457200"/>
-          </a:xfrm>
-          <a:prstGeom prst="rect">
-            <a:avLst/>
-          </a:prstGeom>
-          <a:solidFill>
-            <a:srgbClr val="0E2432"/>
-          </a:solidFill>
-          <a:ln>
-            <a:noFill/>
-          </a:ln>
-        </p:spPr>
-        <p:style>
-          <a:lnRef idx="1">
-            <a:schemeClr val="accent1"/>
-          </a:lnRef>
-          <a:fillRef idx="3">
-            <a:schemeClr val="accent1"/>
-          </a:fillRef>
-          <a:effectRef idx="2">
-            <a:schemeClr val="accent1"/>
-          </a:effectRef>
-          <a:fontRef idx="minor">
-            <a:schemeClr val="lt1"/>
-          </a:fontRef>
-        </p:style>
-        <p:txBody>
-          <a:bodyPr rtlCol="0" anchor="ctr"/>
-          <a:lstStyle/>
-          <a:p>
-            <a:pPr algn="ctr"/>
-            <a:endParaRPr/>
-          </a:p>
-        </p:txBody>
-      </p:sp>
-      <p:sp>
-        <p:nvSpPr>
-          <p:cNvPr id="16" name="TextBox 15"/>
-          <p:cNvSpPr txBox="1"/>
-          <p:nvPr/>
-        </p:nvSpPr>
-        <p:spPr>
-          <a:xfrm>
-            <a:off x="7662672" y="1993392"/>
-            <a:ext cx="2560320" cy="292608"/>
-          </a:xfrm>
-          <a:prstGeom prst="rect">
-            <a:avLst/>
-          </a:prstGeom>
-          <a:noFill/>
-        </p:spPr>
-        <p:txBody>
-          <a:bodyPr wrap="square">
-            <a:spAutoFit/>
-          </a:bodyPr>
-          <a:lstStyle/>
-          <a:p>
-            <a:pPr algn="l"/>
-            <a:r>
-              <a:rPr sz="950" b="0" i="0">
-                <a:solidFill>
-                  <a:srgbClr val="FFFFFF"/>
-                </a:solidFill>
-              </a:rPr>
-              <a:t>Logistic Regression</a:t>
-            </a:r>
-          </a:p>
-        </p:txBody>
-      </p:sp>
-      <p:sp>
-        <p:nvSpPr>
-          <p:cNvPr id="17" name="TextBox 16"/>
-          <p:cNvSpPr txBox="1"/>
-          <p:nvPr/>
-        </p:nvSpPr>
-        <p:spPr>
-          <a:xfrm>
-            <a:off x="10378440" y="1956816"/>
-            <a:ext cx="1371600" cy="365760"/>
-          </a:xfrm>
-          <a:prstGeom prst="rect">
-            <a:avLst/>
-          </a:prstGeom>
-          <a:noFill/>
-        </p:spPr>
-        <p:txBody>
-          <a:bodyPr wrap="square">
-            <a:spAutoFit/>
-          </a:bodyPr>
-          <a:lstStyle/>
-          <a:p>
-            <a:pPr algn="r"/>
-            <a:r>
-              <a:rPr sz="2000" b="1" i="0">
-                <a:solidFill>
-                  <a:srgbClr val="4472A8"/>
-                </a:solidFill>
-              </a:rPr>
-              <a:t>0.877</a:t>
-            </a:r>
-          </a:p>
-        </p:txBody>
-      </p:sp>
-      <p:sp>
-        <p:nvSpPr>
-          <p:cNvPr id="18" name="Rectangle 17"/>
-          <p:cNvSpPr/>
-          <p:nvPr/>
-        </p:nvSpPr>
-        <p:spPr>
-          <a:xfrm>
-            <a:off x="7543800" y="2404872"/>
-            <a:ext cx="4389120" cy="457200"/>
-          </a:xfrm>
-          <a:prstGeom prst="rect">
-            <a:avLst/>
-          </a:prstGeom>
-          <a:solidFill>
-            <a:srgbClr val="0E2432"/>
-          </a:solidFill>
-          <a:ln>
-            <a:noFill/>
-          </a:ln>
-        </p:spPr>
-        <p:style>
-          <a:lnRef idx="1">
-            <a:schemeClr val="accent1"/>
-          </a:lnRef>
-          <a:fillRef idx="3">
-            <a:schemeClr val="accent1"/>
-          </a:fillRef>
-          <a:effectRef idx="2">
-            <a:schemeClr val="accent1"/>
-          </a:effectRef>
-          <a:fontRef idx="minor">
-            <a:schemeClr val="lt1"/>
-          </a:fontRef>
-        </p:style>
-        <p:txBody>
-          <a:bodyPr rtlCol="0" anchor="ctr"/>
-          <a:lstStyle/>
-          <a:p>
-            <a:pPr algn="ctr"/>
-            <a:endParaRPr/>
-          </a:p>
-        </p:txBody>
-      </p:sp>
-      <p:sp>
-        <p:nvSpPr>
-          <p:cNvPr id="19" name="TextBox 18"/>
-          <p:cNvSpPr txBox="1"/>
-          <p:nvPr/>
-        </p:nvSpPr>
-        <p:spPr>
-          <a:xfrm>
-            <a:off x="7662672" y="2496312"/>
-            <a:ext cx="2560320" cy="292608"/>
-          </a:xfrm>
-          <a:prstGeom prst="rect">
-            <a:avLst/>
-          </a:prstGeom>
-          <a:noFill/>
-        </p:spPr>
-        <p:txBody>
-          <a:bodyPr wrap="square">
-            <a:spAutoFit/>
-          </a:bodyPr>
-          <a:lstStyle/>
-          <a:p>
-            <a:pPr algn="l"/>
-            <a:r>
-              <a:rPr sz="950" b="0" i="0">
-                <a:solidFill>
-                  <a:srgbClr val="FFFFFF"/>
-                </a:solidFill>
-              </a:rPr>
-              <a:t>Random Forest (Tuned)</a:t>
-            </a:r>
-          </a:p>
-        </p:txBody>
-      </p:sp>
-      <p:sp>
-        <p:nvSpPr>
-          <p:cNvPr id="20" name="TextBox 19"/>
-          <p:cNvSpPr txBox="1"/>
-          <p:nvPr/>
-        </p:nvSpPr>
-        <p:spPr>
-          <a:xfrm>
-            <a:off x="10378440" y="2459736"/>
-            <a:ext cx="1371600" cy="365760"/>
-          </a:xfrm>
-          <a:prstGeom prst="rect">
-            <a:avLst/>
-          </a:prstGeom>
-          <a:noFill/>
-        </p:spPr>
-        <p:txBody>
-          <a:bodyPr wrap="square">
-            <a:spAutoFit/>
-          </a:bodyPr>
-          <a:lstStyle/>
-          <a:p>
-            <a:pPr algn="r"/>
-            <a:r>
-              <a:rPr sz="2000" b="1" i="0">
-                <a:solidFill>
-                  <a:srgbClr val="B5573A"/>
-                </a:solidFill>
-              </a:rPr>
-              <a:t>0.893</a:t>
-            </a:r>
-          </a:p>
-        </p:txBody>
-      </p:sp>
-      <p:sp>
-        <p:nvSpPr>
-          <p:cNvPr id="21" name="Rectangle 20"/>
-          <p:cNvSpPr/>
-          <p:nvPr/>
-        </p:nvSpPr>
-        <p:spPr>
-          <a:xfrm>
-            <a:off x="7543800" y="2907792"/>
-            <a:ext cx="4389120" cy="630936"/>
-          </a:xfrm>
-          <a:prstGeom prst="rect">
-            <a:avLst/>
-          </a:prstGeom>
-          <a:solidFill>
-            <a:srgbClr val="1B3A4B"/>
-          </a:solidFill>
-          <a:ln>
-            <a:noFill/>
-          </a:ln>
-        </p:spPr>
-        <p:style>
-          <a:lnRef idx="1">
-            <a:schemeClr val="accent1"/>
-          </a:lnRef>
-          <a:fillRef idx="3">
-            <a:schemeClr val="accent1"/>
-          </a:fillRef>
-          <a:effectRef idx="2">
-            <a:schemeClr val="accent1"/>
-          </a:effectRef>
-          <a:fontRef idx="minor">
-            <a:schemeClr val="lt1"/>
-          </a:fontRef>
-        </p:style>
-        <p:txBody>
-          <a:bodyPr rtlCol="0" anchor="ctr"/>
-          <a:lstStyle/>
-          <a:p>
-            <a:pPr algn="ctr"/>
-            <a:endParaRPr/>
-          </a:p>
-        </p:txBody>
-      </p:sp>
-      <p:sp>
-        <p:nvSpPr>
-          <p:cNvPr id="22" name="TextBox 21"/>
-          <p:cNvSpPr txBox="1"/>
-          <p:nvPr/>
-        </p:nvSpPr>
-        <p:spPr>
-          <a:xfrm>
-            <a:off x="7662672" y="2999232"/>
-            <a:ext cx="2560320" cy="292608"/>
-          </a:xfrm>
-          <a:prstGeom prst="rect">
-            <a:avLst/>
-          </a:prstGeom>
-          <a:noFill/>
-        </p:spPr>
-        <p:txBody>
-          <a:bodyPr wrap="square">
-            <a:spAutoFit/>
-          </a:bodyPr>
-          <a:lstStyle/>
-          <a:p>
-            <a:pPr algn="l"/>
-            <a:r>
-              <a:rPr sz="950" b="0" i="0">
-                <a:solidFill>
-                  <a:srgbClr val="FFFFFF"/>
-                </a:solidFill>
-              </a:rPr>
-              <a:t>Random (baseline)</a:t>
-            </a:r>
-          </a:p>
-        </p:txBody>
-      </p:sp>
-      <p:sp>
-        <p:nvSpPr>
-          <p:cNvPr id="23" name="TextBox 22"/>
-          <p:cNvSpPr txBox="1"/>
-          <p:nvPr/>
-        </p:nvSpPr>
-        <p:spPr>
-          <a:xfrm>
-            <a:off x="10378440" y="2962656"/>
-            <a:ext cx="1371600" cy="365760"/>
-          </a:xfrm>
-          <a:prstGeom prst="rect">
-            <a:avLst/>
-          </a:prstGeom>
-          <a:noFill/>
-        </p:spPr>
-        <p:txBody>
-          <a:bodyPr wrap="square">
-            <a:spAutoFit/>
-          </a:bodyPr>
-          <a:lstStyle/>
-          <a:p>
-            <a:pPr algn="r"/>
-            <a:r>
-              <a:rPr sz="2000" b="1" i="0">
-                <a:solidFill>
-                  <a:srgbClr val="5C5C5C"/>
-                </a:solidFill>
-              </a:rPr>
-              <a:t>0.500</a:t>
-            </a:r>
-          </a:p>
-        </p:txBody>
-      </p:sp>
-      <p:sp>
-        <p:nvSpPr>
-          <p:cNvPr id="25" name="TextBox 24"/>
-          <p:cNvSpPr txBox="1"/>
-          <p:nvPr/>
-        </p:nvSpPr>
-        <p:spPr>
-          <a:xfrm>
-            <a:off x="7662672" y="3200400"/>
-            <a:ext cx="4160520" cy="320040"/>
-          </a:xfrm>
-          <a:prstGeom prst="rect">
-            <a:avLst/>
-          </a:prstGeom>
-          <a:noFill/>
-        </p:spPr>
-        <p:txBody>
-          <a:bodyPr wrap="square">
-            <a:spAutoFit/>
-          </a:bodyPr>
-          <a:lstStyle/>
-          <a:p>
-            <a:pPr algn="l"/>
-            <a:r>
-              <a:rPr sz="950" b="1" i="0">
-                <a:solidFill>
-                  <a:srgbClr val="C9A456"/>
-                </a:solidFill>
-              </a:rPr>
-              <a:t>Winner: Random Forest (+1.6% AUC over LR)</a:t>
-            </a:r>
-          </a:p>
-        </p:txBody>
-      </p:sp>
-      <p:sp>
-        <p:nvSpPr>
-          <p:cNvPr id="26" name="Rectangle 25"/>
-          <p:cNvSpPr/>
-          <p:nvPr/>
-        </p:nvSpPr>
-        <p:spPr>
-          <a:xfrm>
-            <a:off x="7543800" y="3703320"/>
-            <a:ext cx="4389120" cy="347472"/>
-          </a:xfrm>
-          <a:prstGeom prst="rect">
-            <a:avLst/>
-          </a:prstGeom>
-          <a:solidFill>
-            <a:srgbClr val="4472A8"/>
-          </a:solidFill>
-          <a:ln>
-            <a:noFill/>
-          </a:ln>
-        </p:spPr>
-        <p:style>
-          <a:lnRef idx="1">
-            <a:schemeClr val="accent1"/>
-          </a:lnRef>
-          <a:fillRef idx="3">
-            <a:schemeClr val="accent1"/>
-          </a:fillRef>
-          <a:effectRef idx="2">
-            <a:schemeClr val="accent1"/>
-          </a:effectRef>
-          <a:fontRef idx="minor">
-            <a:schemeClr val="lt1"/>
-          </a:fontRef>
-        </p:style>
-        <p:txBody>
-          <a:bodyPr rtlCol="0" anchor="ctr"/>
-          <a:lstStyle/>
-          <a:p>
-            <a:pPr algn="ctr"/>
-            <a:endParaRPr/>
-          </a:p>
-        </p:txBody>
-      </p:sp>
-      <p:sp>
-        <p:nvSpPr>
-          <p:cNvPr id="27" name="TextBox 26"/>
-          <p:cNvSpPr txBox="1"/>
-          <p:nvPr/>
-        </p:nvSpPr>
-        <p:spPr>
-          <a:xfrm>
-            <a:off x="7662672" y="3739896"/>
-            <a:ext cx="4160520" cy="274320"/>
-          </a:xfrm>
-          <a:prstGeom prst="rect">
-            <a:avLst/>
-          </a:prstGeom>
-          <a:noFill/>
-        </p:spPr>
-        <p:txBody>
-          <a:bodyPr wrap="square">
-            <a:spAutoFit/>
-          </a:bodyPr>
-          <a:lstStyle/>
-          <a:p>
-            <a:pPr algn="l"/>
-            <a:r>
-              <a:rPr sz="1000" b="1" i="0">
-                <a:solidFill>
-                  <a:srgbClr val="FFFFFF"/>
-                </a:solidFill>
-              </a:rPr>
-              <a:t>What these AUC scores mean</a:t>
-            </a:r>
-          </a:p>
-        </p:txBody>
-      </p:sp>
-      <p:sp>
-        <p:nvSpPr>
-          <p:cNvPr id="28" name="Rectangle 27"/>
-          <p:cNvSpPr/>
-          <p:nvPr/>
-        </p:nvSpPr>
-        <p:spPr>
-          <a:xfrm>
-            <a:off x="7543800" y="4050791"/>
-            <a:ext cx="4389120" cy="1920240"/>
-          </a:xfrm>
-          <a:prstGeom prst="rect">
-            <a:avLst/>
-          </a:prstGeom>
-          <a:solidFill>
-            <a:srgbClr val="EEE8DD"/>
-          </a:solidFill>
-          <a:ln>
-            <a:noFill/>
-          </a:ln>
-        </p:spPr>
-        <p:style>
-          <a:lnRef idx="1">
-            <a:schemeClr val="accent1"/>
-          </a:lnRef>
-          <a:fillRef idx="3">
-            <a:schemeClr val="accent1"/>
-          </a:fillRef>
-          <a:effectRef idx="2">
-            <a:schemeClr val="accent1"/>
-          </a:effectRef>
-          <a:fontRef idx="minor">
-            <a:schemeClr val="lt1"/>
-          </a:fontRef>
-        </p:style>
-        <p:txBody>
-          <a:bodyPr rtlCol="0" anchor="ctr"/>
-          <a:lstStyle/>
-          <a:p>
-            <a:pPr algn="ctr"/>
-            <a:endParaRPr/>
-          </a:p>
-        </p:txBody>
-      </p:sp>
-      <p:sp>
-        <p:nvSpPr>
-          <p:cNvPr id="29" name="TextBox 28"/>
-          <p:cNvSpPr txBox="1"/>
-          <p:nvPr/>
-        </p:nvSpPr>
-        <p:spPr>
-          <a:xfrm>
-            <a:off x="7662672" y="4114800"/>
-            <a:ext cx="4160520" cy="438912"/>
-          </a:xfrm>
-          <a:prstGeom prst="rect">
-            <a:avLst/>
-          </a:prstGeom>
-          <a:noFill/>
-        </p:spPr>
-        <p:txBody>
-          <a:bodyPr wrap="square">
-            <a:spAutoFit/>
-          </a:bodyPr>
-          <a:lstStyle/>
-          <a:p>
-            <a:pPr algn="l"/>
-            <a:r>
-              <a:rPr sz="900" b="0" i="0">
-                <a:solidFill>
-                  <a:srgbClr val="2C2C2C"/>
-                </a:solidFill>
-              </a:rPr>
-              <a:t>▸  AUC 0.893: RF correctly ranks a random fraud
-  claim above a legit one 89.3% of the time</a:t>
-            </a:r>
-          </a:p>
-        </p:txBody>
-      </p:sp>
-      <p:sp>
-        <p:nvSpPr>
-          <p:cNvPr id="30" name="TextBox 29"/>
-          <p:cNvSpPr txBox="1"/>
-          <p:nvPr/>
-        </p:nvSpPr>
-        <p:spPr>
-          <a:xfrm>
-            <a:off x="7662672" y="4572000"/>
-            <a:ext cx="4160520" cy="438912"/>
-          </a:xfrm>
-          <a:prstGeom prst="rect">
-            <a:avLst/>
-          </a:prstGeom>
-          <a:noFill/>
-        </p:spPr>
-        <p:txBody>
-          <a:bodyPr wrap="square">
-            <a:spAutoFit/>
-          </a:bodyPr>
-          <a:lstStyle/>
-          <a:p>
-            <a:pPr algn="l"/>
-            <a:r>
-              <a:rPr sz="900" b="0" i="0">
-                <a:solidFill>
-                  <a:srgbClr val="2C2C2C"/>
-                </a:solidFill>
-              </a:rPr>
-              <a:t>▸  AUC 0.877: LR is also strong — suitable when
-  interpretability is required</a:t>
-            </a:r>
-          </a:p>
-        </p:txBody>
-      </p:sp>
-      <p:sp>
-        <p:nvSpPr>
-          <p:cNvPr id="31" name="TextBox 30"/>
-          <p:cNvSpPr txBox="1"/>
-          <p:nvPr/>
-        </p:nvSpPr>
-        <p:spPr>
-          <a:xfrm>
-            <a:off x="7662672" y="5029200"/>
-            <a:ext cx="4160520" cy="438912"/>
-          </a:xfrm>
-          <a:prstGeom prst="rect">
-            <a:avLst/>
-          </a:prstGeom>
-          <a:noFill/>
-        </p:spPr>
-        <p:txBody>
-          <a:bodyPr wrap="square">
-            <a:spAutoFit/>
-          </a:bodyPr>
-          <a:lstStyle/>
-          <a:p>
-            <a:pPr algn="l"/>
-            <a:r>
-              <a:rPr sz="900" b="0" i="0">
-                <a:solidFill>
-                  <a:srgbClr val="2C2C2C"/>
-                </a:solidFill>
-              </a:rPr>
-              <a:t>▸  Both models far exceed random (0.50),
-  confirming genuine predictive power</a:t>
-            </a:r>
-          </a:p>
-        </p:txBody>
-      </p:sp>
-      <p:sp>
-        <p:nvSpPr>
-          <p:cNvPr id="32" name="TextBox 31"/>
-          <p:cNvSpPr txBox="1"/>
-          <p:nvPr/>
-        </p:nvSpPr>
-        <p:spPr>
-          <a:xfrm>
-            <a:off x="7662672" y="5486400"/>
-            <a:ext cx="4160520" cy="438912"/>
-          </a:xfrm>
-          <a:prstGeom prst="rect">
-            <a:avLst/>
-          </a:prstGeom>
-          <a:noFill/>
-        </p:spPr>
-        <p:txBody>
-          <a:bodyPr wrap="square">
-            <a:spAutoFit/>
-          </a:bodyPr>
-          <a:lstStyle/>
-          <a:p>
-            <a:pPr algn="l"/>
-            <a:r>
-              <a:rPr sz="900" b="0" i="0">
-                <a:solidFill>
-                  <a:srgbClr val="2C2C2C"/>
-                </a:solidFill>
-              </a:rPr>
-              <a:t>▸  Operating point annotated at cutoff 0.5
-  (FPR ≈ 0.15, TPR ≈ 0.81)</a:t>
-            </a:r>
-          </a:p>
-        </p:txBody>
-      </p:sp>
     </p:spTree>
   </p:cSld>
   <p:clrMapOvr>

</xml_diff>